<commit_message>
Added Potential Clients, spelling mistakes, and features
</commit_message>
<xml_diff>
--- a/AppDev2Presentation.pptx
+++ b/AppDev2Presentation.pptx
@@ -11,8 +11,9 @@
     <p:sldId id="259" r:id="rId5"/>
     <p:sldId id="260" r:id="rId6"/>
     <p:sldId id="261" r:id="rId7"/>
-    <p:sldId id="262" r:id="rId8"/>
-    <p:sldId id="263" r:id="rId9"/>
+    <p:sldId id="264" r:id="rId8"/>
+    <p:sldId id="262" r:id="rId9"/>
+    <p:sldId id="263" r:id="rId10"/>
   </p:sldIdLst>
   <p:sldSz cx="12192000" cy="6858000"/>
   <p:notesSz cx="6858000" cy="9144000"/>
@@ -111,6 +112,11 @@
       </a:defRPr>
     </a:lvl9pPr>
   </p:defaultTextStyle>
+  <p:extLst>
+    <p:ext uri="{EFAFB233-063F-42B5-8137-9DF3F51BA10A}">
+      <p15:sldGuideLst xmlns:p15="http://schemas.microsoft.com/office/powerpoint/2012/main"/>
+    </p:ext>
+  </p:extLst>
 </p:presentation>
 </file>
 
@@ -267,7 +273,7 @@
           <a:p>
             <a:fld id="{D1D1EADE-8E88-4C7C-8AC5-FB148DE4940E}" type="datetime1">
               <a:rPr lang="en-US" smtClean="0"/>
-              <a:t>3/26/26</a:t>
+              <a:t>3/26/2026</a:t>
             </a:fld>
             <a:endParaRPr lang="en-US"/>
           </a:p>
@@ -467,7 +473,7 @@
           <a:p>
             <a:fld id="{EC3C8B9C-477D-492A-96AD-1FC2CC997A73}" type="datetime1">
               <a:rPr lang="en-US" smtClean="0"/>
-              <a:t>3/26/26</a:t>
+              <a:t>3/26/2026</a:t>
             </a:fld>
             <a:endParaRPr lang="en-US"/>
           </a:p>
@@ -677,7 +683,7 @@
           <a:p>
             <a:fld id="{42D3AED5-E26D-4E29-B1B3-7847B6779594}" type="datetime1">
               <a:rPr lang="en-US" smtClean="0"/>
-              <a:t>3/26/26</a:t>
+              <a:t>3/26/2026</a:t>
             </a:fld>
             <a:endParaRPr lang="en-US"/>
           </a:p>
@@ -877,7 +883,7 @@
           <a:p>
             <a:fld id="{157B6794-849E-4626-908B-D15793550EFB}" type="datetime1">
               <a:rPr lang="en-US" smtClean="0"/>
-              <a:t>3/26/26</a:t>
+              <a:t>3/26/2026</a:t>
             </a:fld>
             <a:endParaRPr lang="en-US"/>
           </a:p>
@@ -1153,7 +1159,7 @@
           <a:p>
             <a:fld id="{63DB64E7-5594-42A3-ADBF-E95A7ACEAD64}" type="datetime1">
               <a:rPr lang="en-US" smtClean="0"/>
-              <a:t>3/26/26</a:t>
+              <a:t>3/26/2026</a:t>
             </a:fld>
             <a:endParaRPr lang="en-US"/>
           </a:p>
@@ -1426,7 +1432,7 @@
           <a:p>
             <a:fld id="{18462B0B-D248-4FFB-8695-AD7FA4B1284A}" type="datetime1">
               <a:rPr lang="en-US" smtClean="0"/>
-              <a:t>3/26/26</a:t>
+              <a:t>3/26/2026</a:t>
             </a:fld>
             <a:endParaRPr lang="en-US"/>
           </a:p>
@@ -1849,7 +1855,7 @@
           <a:p>
             <a:fld id="{D0378EFB-9159-4510-B73F-4F0409ADE937}" type="datetime1">
               <a:rPr lang="en-US" smtClean="0"/>
-              <a:t>3/26/26</a:t>
+              <a:t>3/26/2026</a:t>
             </a:fld>
             <a:endParaRPr lang="en-US"/>
           </a:p>
@@ -1991,7 +1997,7 @@
           <a:p>
             <a:fld id="{89BC9412-2452-4BED-A324-9D8C115361AD}" type="datetime1">
               <a:rPr lang="en-US" smtClean="0"/>
-              <a:t>3/26/26</a:t>
+              <a:t>3/26/2026</a:t>
             </a:fld>
             <a:endParaRPr lang="en-US"/>
           </a:p>
@@ -2104,7 +2110,7 @@
           <a:p>
             <a:fld id="{F5318F62-D251-40E8-A23C-F4CFE9FEAB41}" type="datetime1">
               <a:rPr lang="en-US" smtClean="0"/>
-              <a:t>3/26/26</a:t>
+              <a:t>3/26/2026</a:t>
             </a:fld>
             <a:endParaRPr lang="en-US"/>
           </a:p>
@@ -2417,7 +2423,7 @@
           <a:p>
             <a:fld id="{44F76144-149E-4874-93A5-554A0357CF82}" type="datetime1">
               <a:rPr lang="en-US" smtClean="0"/>
-              <a:t>3/26/26</a:t>
+              <a:t>3/26/2026</a:t>
             </a:fld>
             <a:endParaRPr lang="en-US"/>
           </a:p>
@@ -2710,7 +2716,7 @@
           <a:p>
             <a:fld id="{50BA65D8-0540-4835-AE5C-25D29DBA01BE}" type="datetime1">
               <a:rPr lang="en-US" smtClean="0"/>
-              <a:t>3/26/26</a:t>
+              <a:t>3/26/2026</a:t>
             </a:fld>
             <a:endParaRPr lang="en-US"/>
           </a:p>
@@ -2952,7 +2958,7 @@
           <a:p>
             <a:fld id="{E31BA835-12AC-4E8F-955A-EA3F4DE2791F}" type="datetime1">
               <a:rPr lang="en-US" smtClean="0"/>
-              <a:t>3/26/26</a:t>
+              <a:t>3/26/2026</a:t>
             </a:fld>
             <a:endParaRPr lang="en-US"/>
           </a:p>
@@ -4197,7 +4203,7 @@
         <p:spPr>
           <a:xfrm>
             <a:off x="6400801" y="2221992"/>
-            <a:ext cx="4991099" cy="6039730"/>
+            <a:ext cx="4991099" cy="6963060"/>
           </a:xfrm>
           <a:prstGeom prst="rect">
             <a:avLst/>
@@ -4232,7 +4238,15 @@
             </a:pPr>
             <a:r>
               <a:rPr lang="en-US" sz="2000" dirty="0"/>
-              <a:t>Upgrade system</a:t>
+              <a:t>Upgrade system(</a:t>
+            </a:r>
+            <a:r>
+              <a:rPr lang="en-US" sz="2000" dirty="0" err="1"/>
+              <a:t>GridView</a:t>
+            </a:r>
+            <a:r>
+              <a:rPr lang="en-US" sz="2000" dirty="0"/>
+              <a:t>)</a:t>
             </a:r>
           </a:p>
           <a:p>
@@ -4258,15 +4272,7 @@
             </a:pPr>
             <a:r>
               <a:rPr lang="en-US" sz="2000" dirty="0"/>
-              <a:t>Settings(change background </a:t>
-            </a:r>
-            <a:r>
-              <a:rPr lang="en-US" sz="2000" dirty="0" err="1"/>
-              <a:t>colour</a:t>
-            </a:r>
-            <a:r>
-              <a:rPr lang="en-US" sz="2000" dirty="0"/>
-              <a:t>)</a:t>
+              <a:t>Settings/Popup menu(change background color)</a:t>
             </a:r>
           </a:p>
           <a:p>
@@ -4277,7 +4283,23 @@
               <a:buFont typeface="Arial" panose="020B0604020202020204" pitchFamily="34" charset="0"/>
               <a:buChar char="•"/>
             </a:pPr>
-            <a:endParaRPr lang="en-US" sz="2000" dirty="0"/>
+            <a:r>
+              <a:rPr lang="en-US" sz="2000" dirty="0"/>
+              <a:t>Splash screen</a:t>
+            </a:r>
+          </a:p>
+          <a:p>
+            <a:pPr marL="285750" indent="-285750">
+              <a:lnSpc>
+                <a:spcPct val="150000"/>
+              </a:lnSpc>
+              <a:buFont typeface="Arial" panose="020B0604020202020204" pitchFamily="34" charset="0"/>
+              <a:buChar char="•"/>
+            </a:pPr>
+            <a:r>
+              <a:rPr lang="en-US" sz="2000" dirty="0"/>
+              <a:t>Multimedia, audio, images, animations</a:t>
+            </a:r>
           </a:p>
           <a:p>
             <a:pPr marL="285750" indent="-285750">
@@ -4524,13 +4546,8 @@
           <a:p>
             <a:r>
               <a:rPr lang="en-US" dirty="0"/>
-              <a:t>Database, backend, </a:t>
-            </a:r>
-            <a:r>
-              <a:rPr lang="en-US" dirty="0" err="1"/>
-              <a:t>FrontEnd</a:t>
-            </a:r>
-            <a:endParaRPr lang="en-US" dirty="0"/>
+              <a:t>Database, backend, Front-End</a:t>
+            </a:r>
           </a:p>
         </p:txBody>
       </p:sp>
@@ -4575,7 +4592,7 @@
           <a:p>
             <a:r>
               <a:rPr lang="en-US" dirty="0"/>
-              <a:t>Sprites will either be gotten online or made by me. (</a:t>
+              <a:t>Sprites will either be gotten online or made by us. (</a:t>
             </a:r>
             <a:r>
               <a:rPr lang="en-US" dirty="0" err="1"/>
@@ -4623,6 +4640,122 @@
           <p:cNvPr id="2" name="Title 1">
             <a:extLst>
               <a:ext uri="{FF2B5EF4-FFF2-40B4-BE49-F238E27FC236}">
+                <a16:creationId xmlns:a16="http://schemas.microsoft.com/office/drawing/2014/main" id="{42D9C641-27EB-1C70-04D6-60504AFD9043}"/>
+              </a:ext>
+            </a:extLst>
+          </p:cNvPr>
+          <p:cNvSpPr>
+            <a:spLocks noGrp="1"/>
+          </p:cNvSpPr>
+          <p:nvPr>
+            <p:ph type="title"/>
+          </p:nvPr>
+        </p:nvSpPr>
+        <p:spPr/>
+        <p:txBody>
+          <a:bodyPr/>
+          <a:lstStyle/>
+          <a:p>
+            <a:r>
+              <a:rPr lang="en-US" dirty="0"/>
+              <a:t>POTENTIAL CLIENTS</a:t>
+            </a:r>
+          </a:p>
+        </p:txBody>
+      </p:sp>
+      <p:sp>
+        <p:nvSpPr>
+          <p:cNvPr id="3" name="Content Placeholder 2">
+            <a:extLst>
+              <a:ext uri="{FF2B5EF4-FFF2-40B4-BE49-F238E27FC236}">
+                <a16:creationId xmlns:a16="http://schemas.microsoft.com/office/drawing/2014/main" id="{F1121B3A-AE74-EF85-B131-D84CDC0C6F84}"/>
+              </a:ext>
+            </a:extLst>
+          </p:cNvPr>
+          <p:cNvSpPr>
+            <a:spLocks noGrp="1"/>
+          </p:cNvSpPr>
+          <p:nvPr>
+            <p:ph idx="1"/>
+          </p:nvPr>
+        </p:nvSpPr>
+        <p:spPr/>
+        <p:txBody>
+          <a:bodyPr/>
+          <a:lstStyle/>
+          <a:p>
+            <a:r>
+              <a:rPr lang="en-US" dirty="0"/>
+              <a:t>Casual gamers</a:t>
+            </a:r>
+          </a:p>
+          <a:p>
+            <a:r>
+              <a:rPr lang="en-US" dirty="0"/>
+              <a:t>Fans of clicker/idle games</a:t>
+            </a:r>
+          </a:p>
+          <a:p>
+            <a:r>
+              <a:rPr lang="en-US" dirty="0"/>
+              <a:t>Mobile gamers</a:t>
+            </a:r>
+          </a:p>
+          <a:p>
+            <a:r>
+              <a:rPr lang="en-US" dirty="0"/>
+              <a:t>Younger player/teens</a:t>
+            </a:r>
+          </a:p>
+          <a:p>
+            <a:r>
+              <a:rPr lang="en-US" dirty="0"/>
+              <a:t>People who enjoy playing less intense games</a:t>
+            </a:r>
+          </a:p>
+          <a:p>
+            <a:r>
+              <a:rPr lang="en-US" dirty="0"/>
+              <a:t>Students/busy people</a:t>
+            </a:r>
+          </a:p>
+        </p:txBody>
+      </p:sp>
+    </p:spTree>
+    <p:extLst>
+      <p:ext uri="{BB962C8B-B14F-4D97-AF65-F5344CB8AC3E}">
+        <p14:creationId xmlns:p14="http://schemas.microsoft.com/office/powerpoint/2010/main" val="1349561733"/>
+      </p:ext>
+    </p:extLst>
+  </p:cSld>
+  <p:clrMapOvr>
+    <a:masterClrMapping/>
+  </p:clrMapOvr>
+</p:sld>
+</file>
+
+<file path=ppt/slides/slide8.xml><?xml version="1.0" encoding="utf-8"?>
+<p:sld xmlns:a="http://schemas.openxmlformats.org/drawingml/2006/main" xmlns:r="http://schemas.openxmlformats.org/officeDocument/2006/relationships" xmlns:p="http://schemas.openxmlformats.org/presentationml/2006/main">
+  <p:cSld>
+    <p:spTree>
+      <p:nvGrpSpPr>
+        <p:cNvPr id="1" name=""/>
+        <p:cNvGrpSpPr/>
+        <p:nvPr/>
+      </p:nvGrpSpPr>
+      <p:grpSpPr>
+        <a:xfrm>
+          <a:off x="0" y="0"/>
+          <a:ext cx="0" cy="0"/>
+          <a:chOff x="0" y="0"/>
+          <a:chExt cx="0" cy="0"/>
+        </a:xfrm>
+      </p:grpSpPr>
+      <p:sp>
+        <p:nvSpPr>
+          <p:cNvPr id="2" name="Title 1">
+            <a:extLst>
+              <a:ext uri="{FF2B5EF4-FFF2-40B4-BE49-F238E27FC236}">
                 <a16:creationId xmlns:a16="http://schemas.microsoft.com/office/drawing/2014/main" id="{7D4E6B90-0C5E-2781-75C1-E49C446B1522}"/>
               </a:ext>
             </a:extLst>
@@ -4733,7 +4866,7 @@
 </p:sld>
 </file>
 
-<file path=ppt/slides/slide8.xml><?xml version="1.0" encoding="utf-8"?>
+<file path=ppt/slides/slide9.xml><?xml version="1.0" encoding="utf-8"?>
 <p:sld xmlns:a="http://schemas.openxmlformats.org/drawingml/2006/main" xmlns:r="http://schemas.openxmlformats.org/officeDocument/2006/relationships" xmlns:p="http://schemas.openxmlformats.org/presentationml/2006/main">
   <p:cSld>
     <p:spTree>

</xml_diff>

<commit_message>
Powerpoint and Mockup done, Changes can be done
</commit_message>
<xml_diff>
--- a/AppDev2Presentation.pptx
+++ b/AppDev2Presentation.pptx
@@ -2,7 +2,7 @@
 <file path=ppt/presentation.xml><?xml version="1.0" encoding="utf-8"?>
 <p:presentation xmlns:a="http://schemas.openxmlformats.org/drawingml/2006/main" xmlns:r="http://schemas.openxmlformats.org/officeDocument/2006/relationships" xmlns:p="http://schemas.openxmlformats.org/presentationml/2006/main" saveSubsetFonts="1" autoCompressPictures="0">
   <p:sldMasterIdLst>
-    <p:sldMasterId id="2147483686" r:id="rId1"/>
+    <p:sldMasterId id="2147483843" r:id="rId1"/>
   </p:sldMasterIdLst>
   <p:sldIdLst>
     <p:sldId id="256" r:id="rId2"/>
@@ -21,7 +21,7 @@
     <a:defPPr>
       <a:defRPr lang="en-US"/>
     </a:defPPr>
-    <a:lvl1pPr marL="0" algn="l" defTabSz="914400" rtl="0" eaLnBrk="1" latinLnBrk="0" hangingPunct="1">
+    <a:lvl1pPr marL="0" algn="l" defTabSz="457200" rtl="0" eaLnBrk="1" latinLnBrk="0" hangingPunct="1">
       <a:defRPr sz="1800" kern="1200">
         <a:solidFill>
           <a:schemeClr val="tx1"/>
@@ -31,7 +31,7 @@
         <a:cs typeface="+mn-cs"/>
       </a:defRPr>
     </a:lvl1pPr>
-    <a:lvl2pPr marL="457200" algn="l" defTabSz="914400" rtl="0" eaLnBrk="1" latinLnBrk="0" hangingPunct="1">
+    <a:lvl2pPr marL="457200" algn="l" defTabSz="457200" rtl="0" eaLnBrk="1" latinLnBrk="0" hangingPunct="1">
       <a:defRPr sz="1800" kern="1200">
         <a:solidFill>
           <a:schemeClr val="tx1"/>
@@ -41,7 +41,7 @@
         <a:cs typeface="+mn-cs"/>
       </a:defRPr>
     </a:lvl2pPr>
-    <a:lvl3pPr marL="914400" algn="l" defTabSz="914400" rtl="0" eaLnBrk="1" latinLnBrk="0" hangingPunct="1">
+    <a:lvl3pPr marL="914400" algn="l" defTabSz="457200" rtl="0" eaLnBrk="1" latinLnBrk="0" hangingPunct="1">
       <a:defRPr sz="1800" kern="1200">
         <a:solidFill>
           <a:schemeClr val="tx1"/>
@@ -51,7 +51,7 @@
         <a:cs typeface="+mn-cs"/>
       </a:defRPr>
     </a:lvl3pPr>
-    <a:lvl4pPr marL="1371600" algn="l" defTabSz="914400" rtl="0" eaLnBrk="1" latinLnBrk="0" hangingPunct="1">
+    <a:lvl4pPr marL="1371600" algn="l" defTabSz="457200" rtl="0" eaLnBrk="1" latinLnBrk="0" hangingPunct="1">
       <a:defRPr sz="1800" kern="1200">
         <a:solidFill>
           <a:schemeClr val="tx1"/>
@@ -61,7 +61,7 @@
         <a:cs typeface="+mn-cs"/>
       </a:defRPr>
     </a:lvl4pPr>
-    <a:lvl5pPr marL="1828800" algn="l" defTabSz="914400" rtl="0" eaLnBrk="1" latinLnBrk="0" hangingPunct="1">
+    <a:lvl5pPr marL="1828800" algn="l" defTabSz="457200" rtl="0" eaLnBrk="1" latinLnBrk="0" hangingPunct="1">
       <a:defRPr sz="1800" kern="1200">
         <a:solidFill>
           <a:schemeClr val="tx1"/>
@@ -71,7 +71,7 @@
         <a:cs typeface="+mn-cs"/>
       </a:defRPr>
     </a:lvl5pPr>
-    <a:lvl6pPr marL="2286000" algn="l" defTabSz="914400" rtl="0" eaLnBrk="1" latinLnBrk="0" hangingPunct="1">
+    <a:lvl6pPr marL="2286000" algn="l" defTabSz="457200" rtl="0" eaLnBrk="1" latinLnBrk="0" hangingPunct="1">
       <a:defRPr sz="1800" kern="1200">
         <a:solidFill>
           <a:schemeClr val="tx1"/>
@@ -81,7 +81,7 @@
         <a:cs typeface="+mn-cs"/>
       </a:defRPr>
     </a:lvl6pPr>
-    <a:lvl7pPr marL="2743200" algn="l" defTabSz="914400" rtl="0" eaLnBrk="1" latinLnBrk="0" hangingPunct="1">
+    <a:lvl7pPr marL="2743200" algn="l" defTabSz="457200" rtl="0" eaLnBrk="1" latinLnBrk="0" hangingPunct="1">
       <a:defRPr sz="1800" kern="1200">
         <a:solidFill>
           <a:schemeClr val="tx1"/>
@@ -91,7 +91,7 @@
         <a:cs typeface="+mn-cs"/>
       </a:defRPr>
     </a:lvl7pPr>
-    <a:lvl8pPr marL="3200400" algn="l" defTabSz="914400" rtl="0" eaLnBrk="1" latinLnBrk="0" hangingPunct="1">
+    <a:lvl8pPr marL="3200400" algn="l" defTabSz="457200" rtl="0" eaLnBrk="1" latinLnBrk="0" hangingPunct="1">
       <a:defRPr sz="1800" kern="1200">
         <a:solidFill>
           <a:schemeClr val="tx1"/>
@@ -101,7 +101,7 @@
         <a:cs typeface="+mn-cs"/>
       </a:defRPr>
     </a:lvl8pPr>
-    <a:lvl9pPr marL="3657600" algn="l" defTabSz="914400" rtl="0" eaLnBrk="1" latinLnBrk="0" hangingPunct="1">
+    <a:lvl9pPr marL="3657600" algn="l" defTabSz="457200" rtl="0" eaLnBrk="1" latinLnBrk="0" hangingPunct="1">
       <a:defRPr sz="1800" kern="1200">
         <a:solidFill>
           <a:schemeClr val="tx1"/>
@@ -139,13 +139,7 @@
       </p:grpSpPr>
       <p:sp>
         <p:nvSpPr>
-          <p:cNvPr id="2" name="Title 1">
-            <a:extLst>
-              <a:ext uri="{FF2B5EF4-FFF2-40B4-BE49-F238E27FC236}">
-                <a16:creationId xmlns:a16="http://schemas.microsoft.com/office/drawing/2014/main" id="{898DE6C8-AB1D-4204-BC9C-3366B0BF0435}"/>
-              </a:ext>
-            </a:extLst>
-          </p:cNvPr>
+          <p:cNvPr id="2" name="Title 1"/>
           <p:cNvSpPr>
             <a:spLocks noGrp="1"/>
           </p:cNvSpPr>
@@ -155,17 +149,17 @@
         </p:nvSpPr>
         <p:spPr>
           <a:xfrm>
-            <a:off x="704088" y="889820"/>
-            <a:ext cx="9989574" cy="3598606"/>
+            <a:off x="1774423" y="802298"/>
+            <a:ext cx="8637073" cy="2920713"/>
           </a:xfrm>
         </p:spPr>
         <p:txBody>
-          <a:bodyPr anchor="t">
+          <a:bodyPr bIns="0" anchor="b">
             <a:normAutofit/>
           </a:bodyPr>
           <a:lstStyle>
-            <a:lvl1pPr algn="l">
-              <a:defRPr sz="5400"/>
+            <a:lvl1pPr algn="ctr">
+              <a:defRPr sz="6600"/>
             </a:lvl1pPr>
           </a:lstStyle>
           <a:p>
@@ -179,13 +173,7 @@
       </p:sp>
       <p:sp>
         <p:nvSpPr>
-          <p:cNvPr id="3" name="Subtitle 2">
-            <a:extLst>
-              <a:ext uri="{FF2B5EF4-FFF2-40B4-BE49-F238E27FC236}">
-                <a16:creationId xmlns:a16="http://schemas.microsoft.com/office/drawing/2014/main" id="{7A7B9009-EE50-4EE5-B6EB-CD6EC83D3FA3}"/>
-              </a:ext>
-            </a:extLst>
-          </p:cNvPr>
+          <p:cNvPr id="3" name="Subtitle 2"/>
           <p:cNvSpPr>
             <a:spLocks noGrp="1"/>
           </p:cNvSpPr>
@@ -195,22 +183,26 @@
         </p:nvSpPr>
         <p:spPr>
           <a:xfrm>
-            <a:off x="704088" y="4488426"/>
-            <a:ext cx="6991776" cy="1302774"/>
+            <a:off x="1774424" y="3724074"/>
+            <a:ext cx="8637072" cy="977621"/>
           </a:xfrm>
         </p:spPr>
         <p:txBody>
-          <a:bodyPr anchor="b">
+          <a:bodyPr tIns="91440" bIns="91440">
             <a:normAutofit/>
           </a:bodyPr>
           <a:lstStyle>
-            <a:lvl1pPr marL="0" indent="0" algn="l">
-              <a:buNone/>
-              <a:defRPr sz="2000"/>
+            <a:lvl1pPr marL="0" indent="0" algn="ctr">
+              <a:buNone/>
+              <a:defRPr sz="1800" b="0" cap="all" baseline="0">
+                <a:solidFill>
+                  <a:schemeClr val="tx1"/>
+                </a:solidFill>
+              </a:defRPr>
             </a:lvl1pPr>
             <a:lvl2pPr marL="457200" indent="0" algn="ctr">
               <a:buNone/>
-              <a:defRPr sz="2000"/>
+              <a:defRPr sz="1800"/>
             </a:lvl2pPr>
             <a:lvl3pPr marL="914400" indent="0" algn="ctr">
               <a:buNone/>
@@ -252,13 +244,7 @@
       </p:sp>
       <p:sp>
         <p:nvSpPr>
-          <p:cNvPr id="4" name="Date Placeholder 3">
-            <a:extLst>
-              <a:ext uri="{FF2B5EF4-FFF2-40B4-BE49-F238E27FC236}">
-                <a16:creationId xmlns:a16="http://schemas.microsoft.com/office/drawing/2014/main" id="{99C8667E-058A-436F-B8EA-5B3A99D43D09}"/>
-              </a:ext>
-            </a:extLst>
-          </p:cNvPr>
+          <p:cNvPr id="4" name="Date Placeholder 3"/>
           <p:cNvSpPr>
             <a:spLocks noGrp="1"/>
           </p:cNvSpPr>
@@ -273,7 +259,7 @@
           <a:p>
             <a:fld id="{D1D1EADE-8E88-4C7C-8AC5-FB148DE4940E}" type="datetime1">
               <a:rPr lang="en-US" smtClean="0"/>
-              <a:t>3/26/2026</a:t>
+              <a:t>3/26/26</a:t>
             </a:fld>
             <a:endParaRPr lang="en-US"/>
           </a:p>
@@ -281,13 +267,7 @@
       </p:sp>
       <p:sp>
         <p:nvSpPr>
-          <p:cNvPr id="5" name="Footer Placeholder 4">
-            <a:extLst>
-              <a:ext uri="{FF2B5EF4-FFF2-40B4-BE49-F238E27FC236}">
-                <a16:creationId xmlns:a16="http://schemas.microsoft.com/office/drawing/2014/main" id="{52680305-1AD7-482D-BFFD-6CDB83AB39A4}"/>
-              </a:ext>
-            </a:extLst>
-          </p:cNvPr>
+          <p:cNvPr id="5" name="Footer Placeholder 4"/>
           <p:cNvSpPr>
             <a:spLocks noGrp="1"/>
           </p:cNvSpPr>
@@ -295,7 +275,12 @@
             <p:ph type="ftr" sz="quarter" idx="11"/>
           </p:nvPr>
         </p:nvSpPr>
-        <p:spPr/>
+        <p:spPr>
+          <a:xfrm>
+            <a:off x="1451579" y="329307"/>
+            <a:ext cx="5626774" cy="309201"/>
+          </a:xfrm>
+        </p:spPr>
         <p:txBody>
           <a:bodyPr/>
           <a:lstStyle/>
@@ -306,13 +291,7 @@
       </p:sp>
       <p:sp>
         <p:nvSpPr>
-          <p:cNvPr id="6" name="Slide Number Placeholder 5">
-            <a:extLst>
-              <a:ext uri="{FF2B5EF4-FFF2-40B4-BE49-F238E27FC236}">
-                <a16:creationId xmlns:a16="http://schemas.microsoft.com/office/drawing/2014/main" id="{BE5762A1-52E9-402D-B65E-DF193E44CE83}"/>
-              </a:ext>
-            </a:extLst>
-          </p:cNvPr>
+          <p:cNvPr id="6" name="Slide Number Placeholder 5"/>
           <p:cNvSpPr>
             <a:spLocks noGrp="1"/>
           </p:cNvSpPr>
@@ -320,7 +299,12 @@
             <p:ph type="sldNum" sz="quarter" idx="12"/>
           </p:nvPr>
         </p:nvSpPr>
-        <p:spPr/>
+        <p:spPr>
+          <a:xfrm>
+            <a:off x="476834" y="798973"/>
+            <a:ext cx="811019" cy="503578"/>
+          </a:xfrm>
+        </p:spPr>
         <p:txBody>
           <a:bodyPr/>
           <a:lstStyle/>
@@ -336,7 +320,7 @@
     </p:spTree>
     <p:extLst>
       <p:ext uri="{BB962C8B-B14F-4D97-AF65-F5344CB8AC3E}">
-        <p14:creationId xmlns:p14="http://schemas.microsoft.com/office/powerpoint/2010/main" val="3426262668"/>
+        <p14:creationId xmlns:p14="http://schemas.microsoft.com/office/powerpoint/2010/main" val="3212220402"/>
       </p:ext>
     </p:extLst>
   </p:cSld>
@@ -365,13 +349,7 @@
       </p:grpSpPr>
       <p:sp>
         <p:nvSpPr>
-          <p:cNvPr id="2" name="Title 1">
-            <a:extLst>
-              <a:ext uri="{FF2B5EF4-FFF2-40B4-BE49-F238E27FC236}">
-                <a16:creationId xmlns:a16="http://schemas.microsoft.com/office/drawing/2014/main" id="{7D6359C1-C098-4BF4-A55D-782F4E606B8A}"/>
-              </a:ext>
-            </a:extLst>
-          </p:cNvPr>
+          <p:cNvPr id="2" name="Title 1"/>
           <p:cNvSpPr>
             <a:spLocks noGrp="1"/>
           </p:cNvSpPr>
@@ -394,13 +372,7 @@
       </p:sp>
       <p:sp>
         <p:nvSpPr>
-          <p:cNvPr id="3" name="Vertical Text Placeholder 2">
-            <a:extLst>
-              <a:ext uri="{FF2B5EF4-FFF2-40B4-BE49-F238E27FC236}">
-                <a16:creationId xmlns:a16="http://schemas.microsoft.com/office/drawing/2014/main" id="{3D343C7E-1E8B-4D38-9B81-1AA2A8978EDE}"/>
-              </a:ext>
-            </a:extLst>
-          </p:cNvPr>
+          <p:cNvPr id="3" name="Vertical Text Placeholder 2"/>
           <p:cNvSpPr>
             <a:spLocks noGrp="1"/>
           </p:cNvSpPr>
@@ -452,13 +424,7 @@
       </p:sp>
       <p:sp>
         <p:nvSpPr>
-          <p:cNvPr id="4" name="Date Placeholder 3">
-            <a:extLst>
-              <a:ext uri="{FF2B5EF4-FFF2-40B4-BE49-F238E27FC236}">
-                <a16:creationId xmlns:a16="http://schemas.microsoft.com/office/drawing/2014/main" id="{C8A70B00-53AE-4D3F-91BE-A8D789ED9864}"/>
-              </a:ext>
-            </a:extLst>
-          </p:cNvPr>
+          <p:cNvPr id="4" name="Date Placeholder 3"/>
           <p:cNvSpPr>
             <a:spLocks noGrp="1"/>
           </p:cNvSpPr>
@@ -473,7 +439,7 @@
           <a:p>
             <a:fld id="{EC3C8B9C-477D-492A-96AD-1FC2CC997A73}" type="datetime1">
               <a:rPr lang="en-US" smtClean="0"/>
-              <a:t>3/26/2026</a:t>
+              <a:t>3/26/26</a:t>
             </a:fld>
             <a:endParaRPr lang="en-US"/>
           </a:p>
@@ -481,13 +447,7 @@
       </p:sp>
       <p:sp>
         <p:nvSpPr>
-          <p:cNvPr id="5" name="Footer Placeholder 4">
-            <a:extLst>
-              <a:ext uri="{FF2B5EF4-FFF2-40B4-BE49-F238E27FC236}">
-                <a16:creationId xmlns:a16="http://schemas.microsoft.com/office/drawing/2014/main" id="{06647FC7-8124-4F70-A849-B6BCC5189CC3}"/>
-              </a:ext>
-            </a:extLst>
-          </p:cNvPr>
+          <p:cNvPr id="5" name="Footer Placeholder 4"/>
           <p:cNvSpPr>
             <a:spLocks noGrp="1"/>
           </p:cNvSpPr>
@@ -506,13 +466,7 @@
       </p:sp>
       <p:sp>
         <p:nvSpPr>
-          <p:cNvPr id="6" name="Slide Number Placeholder 5">
-            <a:extLst>
-              <a:ext uri="{FF2B5EF4-FFF2-40B4-BE49-F238E27FC236}">
-                <a16:creationId xmlns:a16="http://schemas.microsoft.com/office/drawing/2014/main" id="{B47CEBE4-50DC-47DB-B699-CCC024336C9F}"/>
-              </a:ext>
-            </a:extLst>
-          </p:cNvPr>
+          <p:cNvPr id="6" name="Slide Number Placeholder 5"/>
           <p:cNvSpPr>
             <a:spLocks noGrp="1"/>
           </p:cNvSpPr>
@@ -536,7 +490,7 @@
     </p:spTree>
     <p:extLst>
       <p:ext uri="{BB962C8B-B14F-4D97-AF65-F5344CB8AC3E}">
-        <p14:creationId xmlns:p14="http://schemas.microsoft.com/office/powerpoint/2010/main" val="4069511598"/>
+        <p14:creationId xmlns:p14="http://schemas.microsoft.com/office/powerpoint/2010/main" val="1978313830"/>
       </p:ext>
     </p:extLst>
   </p:cSld>
@@ -565,13 +519,7 @@
       </p:grpSpPr>
       <p:sp>
         <p:nvSpPr>
-          <p:cNvPr id="2" name="Vertical Title 1">
-            <a:extLst>
-              <a:ext uri="{FF2B5EF4-FFF2-40B4-BE49-F238E27FC236}">
-                <a16:creationId xmlns:a16="http://schemas.microsoft.com/office/drawing/2014/main" id="{4B418279-D3B8-4C6A-AB74-9DE377771270}"/>
-              </a:ext>
-            </a:extLst>
-          </p:cNvPr>
+          <p:cNvPr id="2" name="Vertical Title 1"/>
           <p:cNvSpPr>
             <a:spLocks noGrp="1"/>
           </p:cNvSpPr>
@@ -581,13 +529,17 @@
         </p:nvSpPr>
         <p:spPr>
           <a:xfrm>
-            <a:off x="9242322" y="997974"/>
-            <a:ext cx="2349043" cy="4984956"/>
+            <a:off x="9127052" y="798973"/>
+            <a:ext cx="1615742" cy="4659889"/>
           </a:xfrm>
         </p:spPr>
         <p:txBody>
           <a:bodyPr vert="eaVert"/>
-          <a:lstStyle/>
+          <a:lstStyle>
+            <a:lvl1pPr algn="l">
+              <a:defRPr/>
+            </a:lvl1pPr>
+          </a:lstStyle>
           <a:p>
             <a:r>
               <a:rPr lang="en-US"/>
@@ -599,13 +551,7 @@
       </p:sp>
       <p:sp>
         <p:nvSpPr>
-          <p:cNvPr id="3" name="Vertical Text Placeholder 2">
-            <a:extLst>
-              <a:ext uri="{FF2B5EF4-FFF2-40B4-BE49-F238E27FC236}">
-                <a16:creationId xmlns:a16="http://schemas.microsoft.com/office/drawing/2014/main" id="{E28F733C-9309-4197-BACA-207CDC8935C9}"/>
-              </a:ext>
-            </a:extLst>
-          </p:cNvPr>
+          <p:cNvPr id="3" name="Vertical Text Placeholder 2"/>
           <p:cNvSpPr>
             <a:spLocks noGrp="1"/>
           </p:cNvSpPr>
@@ -615,8 +561,8 @@
         </p:nvSpPr>
         <p:spPr>
           <a:xfrm>
-            <a:off x="768927" y="997973"/>
-            <a:ext cx="8473395" cy="4984956"/>
+            <a:off x="1444672" y="798973"/>
+            <a:ext cx="7518654" cy="4659889"/>
           </a:xfrm>
         </p:spPr>
         <p:txBody>
@@ -662,13 +608,7 @@
       </p:sp>
       <p:sp>
         <p:nvSpPr>
-          <p:cNvPr id="4" name="Date Placeholder 3">
-            <a:extLst>
-              <a:ext uri="{FF2B5EF4-FFF2-40B4-BE49-F238E27FC236}">
-                <a16:creationId xmlns:a16="http://schemas.microsoft.com/office/drawing/2014/main" id="{56ACD4D0-5BE6-412D-B08B-5DFFD593513E}"/>
-              </a:ext>
-            </a:extLst>
-          </p:cNvPr>
+          <p:cNvPr id="4" name="Date Placeholder 3"/>
           <p:cNvSpPr>
             <a:spLocks noGrp="1"/>
           </p:cNvSpPr>
@@ -683,7 +623,7 @@
           <a:p>
             <a:fld id="{42D3AED5-E26D-4E29-B1B3-7847B6779594}" type="datetime1">
               <a:rPr lang="en-US" smtClean="0"/>
-              <a:t>3/26/2026</a:t>
+              <a:t>3/26/26</a:t>
             </a:fld>
             <a:endParaRPr lang="en-US"/>
           </a:p>
@@ -691,13 +631,7 @@
       </p:sp>
       <p:sp>
         <p:nvSpPr>
-          <p:cNvPr id="5" name="Footer Placeholder 4">
-            <a:extLst>
-              <a:ext uri="{FF2B5EF4-FFF2-40B4-BE49-F238E27FC236}">
-                <a16:creationId xmlns:a16="http://schemas.microsoft.com/office/drawing/2014/main" id="{55021651-B786-4A39-A10F-F5231D0A2C5E}"/>
-              </a:ext>
-            </a:extLst>
-          </p:cNvPr>
+          <p:cNvPr id="5" name="Footer Placeholder 4"/>
           <p:cNvSpPr>
             <a:spLocks noGrp="1"/>
           </p:cNvSpPr>
@@ -716,13 +650,7 @@
       </p:sp>
       <p:sp>
         <p:nvSpPr>
-          <p:cNvPr id="6" name="Slide Number Placeholder 5">
-            <a:extLst>
-              <a:ext uri="{FF2B5EF4-FFF2-40B4-BE49-F238E27FC236}">
-                <a16:creationId xmlns:a16="http://schemas.microsoft.com/office/drawing/2014/main" id="{74504D2D-9379-40DE-9F45-3004BE54F16B}"/>
-              </a:ext>
-            </a:extLst>
-          </p:cNvPr>
+          <p:cNvPr id="6" name="Slide Number Placeholder 5"/>
           <p:cNvSpPr>
             <a:spLocks noGrp="1"/>
           </p:cNvSpPr>
@@ -746,7 +674,7 @@
     </p:spTree>
     <p:extLst>
       <p:ext uri="{BB962C8B-B14F-4D97-AF65-F5344CB8AC3E}">
-        <p14:creationId xmlns:p14="http://schemas.microsoft.com/office/powerpoint/2010/main" val="1687981102"/>
+        <p14:creationId xmlns:p14="http://schemas.microsoft.com/office/powerpoint/2010/main" val="2383530187"/>
       </p:ext>
     </p:extLst>
   </p:cSld>
@@ -775,13 +703,7 @@
       </p:grpSpPr>
       <p:sp>
         <p:nvSpPr>
-          <p:cNvPr id="2" name="Title 1">
-            <a:extLst>
-              <a:ext uri="{FF2B5EF4-FFF2-40B4-BE49-F238E27FC236}">
-                <a16:creationId xmlns:a16="http://schemas.microsoft.com/office/drawing/2014/main" id="{5A987CA6-BFD9-4CB1-8892-F6B062E82445}"/>
-              </a:ext>
-            </a:extLst>
-          </p:cNvPr>
+          <p:cNvPr id="2" name="Title 1"/>
           <p:cNvSpPr>
             <a:spLocks noGrp="1"/>
           </p:cNvSpPr>
@@ -804,13 +726,7 @@
       </p:sp>
       <p:sp>
         <p:nvSpPr>
-          <p:cNvPr id="3" name="Content Placeholder 2">
-            <a:extLst>
-              <a:ext uri="{FF2B5EF4-FFF2-40B4-BE49-F238E27FC236}">
-                <a16:creationId xmlns:a16="http://schemas.microsoft.com/office/drawing/2014/main" id="{E0CDA8C3-9C0C-4E52-9A62-E4DB159E6B0E}"/>
-              </a:ext>
-            </a:extLst>
-          </p:cNvPr>
+          <p:cNvPr id="3" name="Content Placeholder 2"/>
           <p:cNvSpPr>
             <a:spLocks noGrp="1"/>
           </p:cNvSpPr>
@@ -820,7 +736,7 @@
         </p:nvSpPr>
         <p:spPr/>
         <p:txBody>
-          <a:bodyPr/>
+          <a:bodyPr anchor="t"/>
           <a:lstStyle/>
           <a:p>
             <a:pPr lvl="0"/>
@@ -862,13 +778,7 @@
       </p:sp>
       <p:sp>
         <p:nvSpPr>
-          <p:cNvPr id="4" name="Date Placeholder 3">
-            <a:extLst>
-              <a:ext uri="{FF2B5EF4-FFF2-40B4-BE49-F238E27FC236}">
-                <a16:creationId xmlns:a16="http://schemas.microsoft.com/office/drawing/2014/main" id="{7CC3EC35-E02F-41FF-9232-F90692A902FC}"/>
-              </a:ext>
-            </a:extLst>
-          </p:cNvPr>
+          <p:cNvPr id="4" name="Date Placeholder 3"/>
           <p:cNvSpPr>
             <a:spLocks noGrp="1"/>
           </p:cNvSpPr>
@@ -883,7 +793,7 @@
           <a:p>
             <a:fld id="{157B6794-849E-4626-908B-D15793550EFB}" type="datetime1">
               <a:rPr lang="en-US" smtClean="0"/>
-              <a:t>3/26/2026</a:t>
+              <a:t>3/26/26</a:t>
             </a:fld>
             <a:endParaRPr lang="en-US"/>
           </a:p>
@@ -891,13 +801,7 @@
       </p:sp>
       <p:sp>
         <p:nvSpPr>
-          <p:cNvPr id="5" name="Footer Placeholder 4">
-            <a:extLst>
-              <a:ext uri="{FF2B5EF4-FFF2-40B4-BE49-F238E27FC236}">
-                <a16:creationId xmlns:a16="http://schemas.microsoft.com/office/drawing/2014/main" id="{39D13D38-5DF1-443B-8A12-71E834FDC6A1}"/>
-              </a:ext>
-            </a:extLst>
-          </p:cNvPr>
+          <p:cNvPr id="5" name="Footer Placeholder 4"/>
           <p:cNvSpPr>
             <a:spLocks noGrp="1"/>
           </p:cNvSpPr>
@@ -916,13 +820,7 @@
       </p:sp>
       <p:sp>
         <p:nvSpPr>
-          <p:cNvPr id="6" name="Slide Number Placeholder 5">
-            <a:extLst>
-              <a:ext uri="{FF2B5EF4-FFF2-40B4-BE49-F238E27FC236}">
-                <a16:creationId xmlns:a16="http://schemas.microsoft.com/office/drawing/2014/main" id="{F25E644A-4A37-4757-9809-5B035E2874E6}"/>
-              </a:ext>
-            </a:extLst>
-          </p:cNvPr>
+          <p:cNvPr id="6" name="Slide Number Placeholder 5"/>
           <p:cNvSpPr>
             <a:spLocks noGrp="1"/>
           </p:cNvSpPr>
@@ -946,7 +844,7 @@
     </p:spTree>
     <p:extLst>
       <p:ext uri="{BB962C8B-B14F-4D97-AF65-F5344CB8AC3E}">
-        <p14:creationId xmlns:p14="http://schemas.microsoft.com/office/powerpoint/2010/main" val="319843629"/>
+        <p14:creationId xmlns:p14="http://schemas.microsoft.com/office/powerpoint/2010/main" val="2765688457"/>
       </p:ext>
     </p:extLst>
   </p:cSld>
@@ -975,13 +873,7 @@
       </p:grpSpPr>
       <p:sp>
         <p:nvSpPr>
-          <p:cNvPr id="2" name="Title 1">
-            <a:extLst>
-              <a:ext uri="{FF2B5EF4-FFF2-40B4-BE49-F238E27FC236}">
-                <a16:creationId xmlns:a16="http://schemas.microsoft.com/office/drawing/2014/main" id="{70E6578B-CD85-4BF1-A729-E8E8079B595F}"/>
-              </a:ext>
-            </a:extLst>
-          </p:cNvPr>
+          <p:cNvPr id="2" name="Title 1"/>
           <p:cNvSpPr>
             <a:spLocks noGrp="1"/>
           </p:cNvSpPr>
@@ -991,15 +883,17 @@
         </p:nvSpPr>
         <p:spPr>
           <a:xfrm>
-            <a:off x="715383" y="1709738"/>
-            <a:ext cx="10632067" cy="2852737"/>
+            <a:off x="1774423" y="1756130"/>
+            <a:ext cx="8643154" cy="1969007"/>
           </a:xfrm>
         </p:spPr>
         <p:txBody>
-          <a:bodyPr anchor="b"/>
+          <a:bodyPr anchor="b">
+            <a:normAutofit/>
+          </a:bodyPr>
           <a:lstStyle>
-            <a:lvl1pPr>
-              <a:defRPr sz="6000"/>
+            <a:lvl1pPr algn="ctr">
+              <a:defRPr sz="3600"/>
             </a:lvl1pPr>
           </a:lstStyle>
           <a:p>
@@ -1013,13 +907,7 @@
       </p:sp>
       <p:sp>
         <p:nvSpPr>
-          <p:cNvPr id="3" name="Text Placeholder 2">
-            <a:extLst>
-              <a:ext uri="{FF2B5EF4-FFF2-40B4-BE49-F238E27FC236}">
-                <a16:creationId xmlns:a16="http://schemas.microsoft.com/office/drawing/2014/main" id="{A58448C1-C13F-4826-8347-EEB00A6643D6}"/>
-              </a:ext>
-            </a:extLst>
-          </p:cNvPr>
+          <p:cNvPr id="3" name="Text Placeholder 2"/>
           <p:cNvSpPr>
             <a:spLocks noGrp="1"/>
           </p:cNvSpPr>
@@ -1029,26 +917,26 @@
         </p:nvSpPr>
         <p:spPr>
           <a:xfrm>
-            <a:off x="715383" y="4589463"/>
-            <a:ext cx="10632067" cy="1500187"/>
+            <a:off x="1774423" y="3725137"/>
+            <a:ext cx="8643154" cy="1093987"/>
           </a:xfrm>
         </p:spPr>
         <p:txBody>
-          <a:bodyPr/>
+          <a:bodyPr tIns="91440">
+            <a:normAutofit/>
+          </a:bodyPr>
           <a:lstStyle>
-            <a:lvl1pPr marL="0" indent="0">
-              <a:buNone/>
-              <a:defRPr sz="2400">
+            <a:lvl1pPr marL="0" indent="0" algn="ctr">
+              <a:buNone/>
+              <a:defRPr sz="1800">
                 <a:solidFill>
-                  <a:schemeClr val="tx1">
-                    <a:tint val="75000"/>
-                  </a:schemeClr>
+                  <a:schemeClr val="tx1"/>
                 </a:solidFill>
               </a:defRPr>
             </a:lvl1pPr>
             <a:lvl2pPr marL="457200" indent="0">
               <a:buNone/>
-              <a:defRPr sz="2000">
+              <a:defRPr sz="1800">
                 <a:solidFill>
                   <a:schemeClr val="tx1">
                     <a:tint val="75000"/>
@@ -1138,13 +1026,7 @@
       </p:sp>
       <p:sp>
         <p:nvSpPr>
-          <p:cNvPr id="4" name="Date Placeholder 3">
-            <a:extLst>
-              <a:ext uri="{FF2B5EF4-FFF2-40B4-BE49-F238E27FC236}">
-                <a16:creationId xmlns:a16="http://schemas.microsoft.com/office/drawing/2014/main" id="{5806546A-957F-4C4D-9744-1177AD258E10}"/>
-              </a:ext>
-            </a:extLst>
-          </p:cNvPr>
+          <p:cNvPr id="4" name="Date Placeholder 3"/>
           <p:cNvSpPr>
             <a:spLocks noGrp="1"/>
           </p:cNvSpPr>
@@ -1159,7 +1041,7 @@
           <a:p>
             <a:fld id="{63DB64E7-5594-42A3-ADBF-E95A7ACEAD64}" type="datetime1">
               <a:rPr lang="en-US" smtClean="0"/>
-              <a:t>3/26/2026</a:t>
+              <a:t>3/26/26</a:t>
             </a:fld>
             <a:endParaRPr lang="en-US"/>
           </a:p>
@@ -1167,13 +1049,7 @@
       </p:sp>
       <p:sp>
         <p:nvSpPr>
-          <p:cNvPr id="5" name="Footer Placeholder 4">
-            <a:extLst>
-              <a:ext uri="{FF2B5EF4-FFF2-40B4-BE49-F238E27FC236}">
-                <a16:creationId xmlns:a16="http://schemas.microsoft.com/office/drawing/2014/main" id="{B1DB149C-CC63-4E3A-A83D-EF637EB51979}"/>
-              </a:ext>
-            </a:extLst>
-          </p:cNvPr>
+          <p:cNvPr id="5" name="Footer Placeholder 4"/>
           <p:cNvSpPr>
             <a:spLocks noGrp="1"/>
           </p:cNvSpPr>
@@ -1192,13 +1068,7 @@
       </p:sp>
       <p:sp>
         <p:nvSpPr>
-          <p:cNvPr id="6" name="Slide Number Placeholder 5">
-            <a:extLst>
-              <a:ext uri="{FF2B5EF4-FFF2-40B4-BE49-F238E27FC236}">
-                <a16:creationId xmlns:a16="http://schemas.microsoft.com/office/drawing/2014/main" id="{EDB94775-7982-41EC-B584-D51224D38F77}"/>
-              </a:ext>
-            </a:extLst>
-          </p:cNvPr>
+          <p:cNvPr id="6" name="Slide Number Placeholder 5"/>
           <p:cNvSpPr>
             <a:spLocks noGrp="1"/>
           </p:cNvSpPr>
@@ -1222,7 +1092,7 @@
     </p:spTree>
     <p:extLst>
       <p:ext uri="{BB962C8B-B14F-4D97-AF65-F5344CB8AC3E}">
-        <p14:creationId xmlns:p14="http://schemas.microsoft.com/office/powerpoint/2010/main" val="2020719013"/>
+        <p14:creationId xmlns:p14="http://schemas.microsoft.com/office/powerpoint/2010/main" val="3501790073"/>
       </p:ext>
     </p:extLst>
   </p:cSld>
@@ -1251,13 +1121,7 @@
       </p:grpSpPr>
       <p:sp>
         <p:nvSpPr>
-          <p:cNvPr id="2" name="Title 1">
-            <a:extLst>
-              <a:ext uri="{FF2B5EF4-FFF2-40B4-BE49-F238E27FC236}">
-                <a16:creationId xmlns:a16="http://schemas.microsoft.com/office/drawing/2014/main" id="{88CE4BD8-507D-48E4-A624-F16A741C3609}"/>
-              </a:ext>
-            </a:extLst>
-          </p:cNvPr>
+          <p:cNvPr id="2" name="Title 1"/>
           <p:cNvSpPr>
             <a:spLocks noGrp="1"/>
           </p:cNvSpPr>
@@ -1267,8 +1131,8 @@
         </p:nvSpPr>
         <p:spPr>
           <a:xfrm>
-            <a:off x="700635" y="914400"/>
-            <a:ext cx="10691265" cy="1307592"/>
+            <a:off x="1449217" y="804889"/>
+            <a:ext cx="9293577" cy="1059305"/>
           </a:xfrm>
         </p:spPr>
         <p:txBody>
@@ -1285,13 +1149,7 @@
       </p:sp>
       <p:sp>
         <p:nvSpPr>
-          <p:cNvPr id="3" name="Content Placeholder 2">
-            <a:extLst>
-              <a:ext uri="{FF2B5EF4-FFF2-40B4-BE49-F238E27FC236}">
-                <a16:creationId xmlns:a16="http://schemas.microsoft.com/office/drawing/2014/main" id="{810A07E4-3A39-457C-A059-7DFB6039D947}"/>
-              </a:ext>
-            </a:extLst>
-          </p:cNvPr>
+          <p:cNvPr id="3" name="Content Placeholder 2"/>
           <p:cNvSpPr>
             <a:spLocks noGrp="1"/>
           </p:cNvSpPr>
@@ -1301,8 +1159,8 @@
         </p:nvSpPr>
         <p:spPr>
           <a:xfrm>
-            <a:off x="704088" y="2221992"/>
-            <a:ext cx="5212080" cy="3739896"/>
+            <a:off x="1447331" y="2010878"/>
+            <a:ext cx="4488654" cy="3448595"/>
           </a:xfrm>
         </p:spPr>
         <p:txBody>
@@ -1348,13 +1206,7 @@
       </p:sp>
       <p:sp>
         <p:nvSpPr>
-          <p:cNvPr id="4" name="Content Placeholder 3">
-            <a:extLst>
-              <a:ext uri="{FF2B5EF4-FFF2-40B4-BE49-F238E27FC236}">
-                <a16:creationId xmlns:a16="http://schemas.microsoft.com/office/drawing/2014/main" id="{7B141E17-47CE-4A78-B0FA-0E9786DA67C5}"/>
-              </a:ext>
-            </a:extLst>
-          </p:cNvPr>
+          <p:cNvPr id="4" name="Content Placeholder 3"/>
           <p:cNvSpPr>
             <a:spLocks noGrp="1"/>
           </p:cNvSpPr>
@@ -1364,8 +1216,8 @@
         </p:nvSpPr>
         <p:spPr>
           <a:xfrm>
-            <a:off x="6181344" y="2221992"/>
-            <a:ext cx="5212080" cy="3739896"/>
+            <a:off x="6254140" y="2017343"/>
+            <a:ext cx="4488654" cy="3441520"/>
           </a:xfrm>
         </p:spPr>
         <p:txBody>
@@ -1411,13 +1263,7 @@
       </p:sp>
       <p:sp>
         <p:nvSpPr>
-          <p:cNvPr id="5" name="Date Placeholder 4">
-            <a:extLst>
-              <a:ext uri="{FF2B5EF4-FFF2-40B4-BE49-F238E27FC236}">
-                <a16:creationId xmlns:a16="http://schemas.microsoft.com/office/drawing/2014/main" id="{89F02C13-D3ED-4044-9716-F29D79A184C9}"/>
-              </a:ext>
-            </a:extLst>
-          </p:cNvPr>
+          <p:cNvPr id="5" name="Date Placeholder 4"/>
           <p:cNvSpPr>
             <a:spLocks noGrp="1"/>
           </p:cNvSpPr>
@@ -1432,7 +1278,7 @@
           <a:p>
             <a:fld id="{18462B0B-D248-4FFB-8695-AD7FA4B1284A}" type="datetime1">
               <a:rPr lang="en-US" smtClean="0"/>
-              <a:t>3/26/2026</a:t>
+              <a:t>3/26/26</a:t>
             </a:fld>
             <a:endParaRPr lang="en-US"/>
           </a:p>
@@ -1440,13 +1286,7 @@
       </p:sp>
       <p:sp>
         <p:nvSpPr>
-          <p:cNvPr id="6" name="Footer Placeholder 5">
-            <a:extLst>
-              <a:ext uri="{FF2B5EF4-FFF2-40B4-BE49-F238E27FC236}">
-                <a16:creationId xmlns:a16="http://schemas.microsoft.com/office/drawing/2014/main" id="{8AF334AD-FB29-4355-B5CF-85E61B4F3409}"/>
-              </a:ext>
-            </a:extLst>
-          </p:cNvPr>
+          <p:cNvPr id="6" name="Footer Placeholder 5"/>
           <p:cNvSpPr>
             <a:spLocks noGrp="1"/>
           </p:cNvSpPr>
@@ -1465,13 +1305,7 @@
       </p:sp>
       <p:sp>
         <p:nvSpPr>
-          <p:cNvPr id="7" name="Slide Number Placeholder 6">
-            <a:extLst>
-              <a:ext uri="{FF2B5EF4-FFF2-40B4-BE49-F238E27FC236}">
-                <a16:creationId xmlns:a16="http://schemas.microsoft.com/office/drawing/2014/main" id="{BA5AA154-790C-4774-9C21-8C543E733F26}"/>
-              </a:ext>
-            </a:extLst>
-          </p:cNvPr>
+          <p:cNvPr id="7" name="Slide Number Placeholder 6"/>
           <p:cNvSpPr>
             <a:spLocks noGrp="1"/>
           </p:cNvSpPr>
@@ -1495,7 +1329,7 @@
     </p:spTree>
     <p:extLst>
       <p:ext uri="{BB962C8B-B14F-4D97-AF65-F5344CB8AC3E}">
-        <p14:creationId xmlns:p14="http://schemas.microsoft.com/office/powerpoint/2010/main" val="933828502"/>
+        <p14:creationId xmlns:p14="http://schemas.microsoft.com/office/powerpoint/2010/main" val="3197201163"/>
       </p:ext>
     </p:extLst>
   </p:cSld>
@@ -1524,13 +1358,7 @@
       </p:grpSpPr>
       <p:sp>
         <p:nvSpPr>
-          <p:cNvPr id="2" name="Title 1">
-            <a:extLst>
-              <a:ext uri="{FF2B5EF4-FFF2-40B4-BE49-F238E27FC236}">
-                <a16:creationId xmlns:a16="http://schemas.microsoft.com/office/drawing/2014/main" id="{9E07DD35-7673-4F88-86B0-634883B5E345}"/>
-              </a:ext>
-            </a:extLst>
-          </p:cNvPr>
+          <p:cNvPr id="2" name="Title 1"/>
           <p:cNvSpPr>
             <a:spLocks noGrp="1"/>
           </p:cNvSpPr>
@@ -1540,8 +1368,8 @@
         </p:nvSpPr>
         <p:spPr>
           <a:xfrm>
-            <a:off x="704087" y="929147"/>
-            <a:ext cx="10689336" cy="798451"/>
+            <a:off x="1447191" y="804163"/>
+            <a:ext cx="9295603" cy="1056319"/>
           </a:xfrm>
         </p:spPr>
         <p:txBody>
@@ -1558,13 +1386,7 @@
       </p:sp>
       <p:sp>
         <p:nvSpPr>
-          <p:cNvPr id="3" name="Text Placeholder 2">
-            <a:extLst>
-              <a:ext uri="{FF2B5EF4-FFF2-40B4-BE49-F238E27FC236}">
-                <a16:creationId xmlns:a16="http://schemas.microsoft.com/office/drawing/2014/main" id="{5EC820D7-3E0B-47C6-A583-C4C839C5AF03}"/>
-              </a:ext>
-            </a:extLst>
-          </p:cNvPr>
+          <p:cNvPr id="3" name="Text Placeholder 2"/>
           <p:cNvSpPr>
             <a:spLocks noGrp="1"/>
           </p:cNvSpPr>
@@ -1574,8 +1396,8 @@
         </p:nvSpPr>
         <p:spPr>
           <a:xfrm>
-            <a:off x="704088" y="1756538"/>
-            <a:ext cx="5212080" cy="657225"/>
+            <a:off x="1447191" y="2019549"/>
+            <a:ext cx="4488794" cy="801943"/>
           </a:xfrm>
         </p:spPr>
         <p:txBody>
@@ -1584,9 +1406,14 @@
           </a:bodyPr>
           <a:lstStyle>
             <a:lvl1pPr marL="0" indent="0">
-              <a:buNone/>
-              <a:defRPr sz="1600" b="1">
-                <a:latin typeface="+mj-lt"/>
+              <a:lnSpc>
+                <a:spcPct val="100000"/>
+              </a:lnSpc>
+              <a:buNone/>
+              <a:defRPr sz="2200" b="0" cap="all" baseline="0">
+                <a:solidFill>
+                  <a:schemeClr val="accent1"/>
+                </a:solidFill>
               </a:defRPr>
             </a:lvl1pPr>
             <a:lvl2pPr marL="457200" indent="0">
@@ -1633,13 +1460,7 @@
       </p:sp>
       <p:sp>
         <p:nvSpPr>
-          <p:cNvPr id="4" name="Content Placeholder 3">
-            <a:extLst>
-              <a:ext uri="{FF2B5EF4-FFF2-40B4-BE49-F238E27FC236}">
-                <a16:creationId xmlns:a16="http://schemas.microsoft.com/office/drawing/2014/main" id="{6A839A7B-97D5-400F-B802-A0FF28FE9F15}"/>
-              </a:ext>
-            </a:extLst>
-          </p:cNvPr>
+          <p:cNvPr id="4" name="Content Placeholder 3"/>
           <p:cNvSpPr>
             <a:spLocks noGrp="1"/>
           </p:cNvSpPr>
@@ -1649,8 +1470,8 @@
         </p:nvSpPr>
         <p:spPr>
           <a:xfrm>
-            <a:off x="704088" y="2442702"/>
-            <a:ext cx="5212080" cy="3519185"/>
+            <a:off x="1447191" y="2824269"/>
+            <a:ext cx="4488794" cy="2644457"/>
           </a:xfrm>
         </p:spPr>
         <p:txBody>
@@ -1696,13 +1517,7 @@
       </p:sp>
       <p:sp>
         <p:nvSpPr>
-          <p:cNvPr id="5" name="Text Placeholder 4">
-            <a:extLst>
-              <a:ext uri="{FF2B5EF4-FFF2-40B4-BE49-F238E27FC236}">
-                <a16:creationId xmlns:a16="http://schemas.microsoft.com/office/drawing/2014/main" id="{C2E0ECA2-DBF1-4681-9DFA-93AFD1B371DB}"/>
-              </a:ext>
-            </a:extLst>
-          </p:cNvPr>
+          <p:cNvPr id="5" name="Text Placeholder 4"/>
           <p:cNvSpPr>
             <a:spLocks noGrp="1"/>
           </p:cNvSpPr>
@@ -1712,8 +1527,8 @@
         </p:nvSpPr>
         <p:spPr>
           <a:xfrm>
-            <a:off x="6181344" y="1756538"/>
-            <a:ext cx="5212080" cy="657225"/>
+            <a:off x="6256025" y="2023003"/>
+            <a:ext cx="4488794" cy="802237"/>
           </a:xfrm>
         </p:spPr>
         <p:txBody>
@@ -1722,9 +1537,14 @@
           </a:bodyPr>
           <a:lstStyle>
             <a:lvl1pPr marL="0" indent="0">
-              <a:buNone/>
-              <a:defRPr sz="1600" b="1">
-                <a:latin typeface="+mj-lt"/>
+              <a:lnSpc>
+                <a:spcPct val="100000"/>
+              </a:lnSpc>
+              <a:buNone/>
+              <a:defRPr sz="2200" b="0" cap="all" baseline="0">
+                <a:solidFill>
+                  <a:schemeClr val="accent1"/>
+                </a:solidFill>
               </a:defRPr>
             </a:lvl1pPr>
             <a:lvl2pPr marL="457200" indent="0">
@@ -1771,13 +1591,7 @@
       </p:sp>
       <p:sp>
         <p:nvSpPr>
-          <p:cNvPr id="6" name="Content Placeholder 5">
-            <a:extLst>
-              <a:ext uri="{FF2B5EF4-FFF2-40B4-BE49-F238E27FC236}">
-                <a16:creationId xmlns:a16="http://schemas.microsoft.com/office/drawing/2014/main" id="{390EBBBB-517F-4ED7-9E51-CF0F7590B4D4}"/>
-              </a:ext>
-            </a:extLst>
-          </p:cNvPr>
+          <p:cNvPr id="6" name="Content Placeholder 5"/>
           <p:cNvSpPr>
             <a:spLocks noGrp="1"/>
           </p:cNvSpPr>
@@ -1787,8 +1601,8 @@
         </p:nvSpPr>
         <p:spPr>
           <a:xfrm>
-            <a:off x="6181344" y="2442702"/>
-            <a:ext cx="5212080" cy="3519185"/>
+            <a:off x="6256025" y="2821491"/>
+            <a:ext cx="4488794" cy="2637371"/>
           </a:xfrm>
         </p:spPr>
         <p:txBody>
@@ -1834,13 +1648,7 @@
       </p:sp>
       <p:sp>
         <p:nvSpPr>
-          <p:cNvPr id="7" name="Date Placeholder 6">
-            <a:extLst>
-              <a:ext uri="{FF2B5EF4-FFF2-40B4-BE49-F238E27FC236}">
-                <a16:creationId xmlns:a16="http://schemas.microsoft.com/office/drawing/2014/main" id="{2511B5C7-1E37-478F-B4B0-C7202FFE41B9}"/>
-              </a:ext>
-            </a:extLst>
-          </p:cNvPr>
+          <p:cNvPr id="7" name="Date Placeholder 6"/>
           <p:cNvSpPr>
             <a:spLocks noGrp="1"/>
           </p:cNvSpPr>
@@ -1853,9 +1661,9 @@
           <a:bodyPr/>
           <a:lstStyle/>
           <a:p>
-            <a:fld id="{D0378EFB-9159-4510-B73F-4F0409ADE937}" type="datetime1">
+            <a:fld id="{E31BA835-12AC-4E8F-955A-EA3F4DE2791F}" type="datetime1">
               <a:rPr lang="en-US" smtClean="0"/>
-              <a:t>3/26/2026</a:t>
+              <a:t>3/26/26</a:t>
             </a:fld>
             <a:endParaRPr lang="en-US"/>
           </a:p>
@@ -1863,13 +1671,7 @@
       </p:sp>
       <p:sp>
         <p:nvSpPr>
-          <p:cNvPr id="8" name="Footer Placeholder 7">
-            <a:extLst>
-              <a:ext uri="{FF2B5EF4-FFF2-40B4-BE49-F238E27FC236}">
-                <a16:creationId xmlns:a16="http://schemas.microsoft.com/office/drawing/2014/main" id="{9153F7EF-507C-4CB3-86C5-8B34FFFC1D86}"/>
-              </a:ext>
-            </a:extLst>
-          </p:cNvPr>
+          <p:cNvPr id="8" name="Footer Placeholder 7"/>
           <p:cNvSpPr>
             <a:spLocks noGrp="1"/>
           </p:cNvSpPr>
@@ -1888,13 +1690,7 @@
       </p:sp>
       <p:sp>
         <p:nvSpPr>
-          <p:cNvPr id="9" name="Slide Number Placeholder 8">
-            <a:extLst>
-              <a:ext uri="{FF2B5EF4-FFF2-40B4-BE49-F238E27FC236}">
-                <a16:creationId xmlns:a16="http://schemas.microsoft.com/office/drawing/2014/main" id="{58E3DEA6-E4EB-4C2A-8B4F-55EC965B6219}"/>
-              </a:ext>
-            </a:extLst>
-          </p:cNvPr>
+          <p:cNvPr id="9" name="Slide Number Placeholder 8"/>
           <p:cNvSpPr>
             <a:spLocks noGrp="1"/>
           </p:cNvSpPr>
@@ -1918,13 +1714,14 @@
     </p:spTree>
     <p:extLst>
       <p:ext uri="{BB962C8B-B14F-4D97-AF65-F5344CB8AC3E}">
-        <p14:creationId xmlns:p14="http://schemas.microsoft.com/office/powerpoint/2010/main" val="3764289591"/>
+        <p14:creationId xmlns:p14="http://schemas.microsoft.com/office/powerpoint/2010/main" val="3237576133"/>
       </p:ext>
     </p:extLst>
   </p:cSld>
   <p:clrMapOvr>
     <a:masterClrMapping/>
   </p:clrMapOvr>
+  <p:hf sldNum="0" hdr="0" ftr="0" dt="0"/>
 </p:sldLayout>
 </file>
 
@@ -1947,13 +1744,7 @@
       </p:grpSpPr>
       <p:sp>
         <p:nvSpPr>
-          <p:cNvPr id="2" name="Title 1">
-            <a:extLst>
-              <a:ext uri="{FF2B5EF4-FFF2-40B4-BE49-F238E27FC236}">
-                <a16:creationId xmlns:a16="http://schemas.microsoft.com/office/drawing/2014/main" id="{38032964-A933-4B98-A141-A4B316DAFA9F}"/>
-              </a:ext>
-            </a:extLst>
-          </p:cNvPr>
+          <p:cNvPr id="2" name="Title 1"/>
           <p:cNvSpPr>
             <a:spLocks noGrp="1"/>
           </p:cNvSpPr>
@@ -1976,13 +1767,7 @@
       </p:sp>
       <p:sp>
         <p:nvSpPr>
-          <p:cNvPr id="3" name="Date Placeholder 2">
-            <a:extLst>
-              <a:ext uri="{FF2B5EF4-FFF2-40B4-BE49-F238E27FC236}">
-                <a16:creationId xmlns:a16="http://schemas.microsoft.com/office/drawing/2014/main" id="{5D684C9D-23DA-42B0-9DD3-7592F72E8DC9}"/>
-              </a:ext>
-            </a:extLst>
-          </p:cNvPr>
+          <p:cNvPr id="3" name="Date Placeholder 2"/>
           <p:cNvSpPr>
             <a:spLocks noGrp="1"/>
           </p:cNvSpPr>
@@ -1997,7 +1782,7 @@
           <a:p>
             <a:fld id="{89BC9412-2452-4BED-A324-9D8C115361AD}" type="datetime1">
               <a:rPr lang="en-US" smtClean="0"/>
-              <a:t>3/26/2026</a:t>
+              <a:t>3/26/26</a:t>
             </a:fld>
             <a:endParaRPr lang="en-US"/>
           </a:p>
@@ -2005,13 +1790,7 @@
       </p:sp>
       <p:sp>
         <p:nvSpPr>
-          <p:cNvPr id="4" name="Footer Placeholder 3">
-            <a:extLst>
-              <a:ext uri="{FF2B5EF4-FFF2-40B4-BE49-F238E27FC236}">
-                <a16:creationId xmlns:a16="http://schemas.microsoft.com/office/drawing/2014/main" id="{68BF8F05-876F-49D8-AE30-5BB2A91ECD59}"/>
-              </a:ext>
-            </a:extLst>
-          </p:cNvPr>
+          <p:cNvPr id="4" name="Footer Placeholder 3"/>
           <p:cNvSpPr>
             <a:spLocks noGrp="1"/>
           </p:cNvSpPr>
@@ -2030,13 +1809,7 @@
       </p:sp>
       <p:sp>
         <p:nvSpPr>
-          <p:cNvPr id="5" name="Slide Number Placeholder 4">
-            <a:extLst>
-              <a:ext uri="{FF2B5EF4-FFF2-40B4-BE49-F238E27FC236}">
-                <a16:creationId xmlns:a16="http://schemas.microsoft.com/office/drawing/2014/main" id="{153D20DA-9260-4577-BB51-789570A243AF}"/>
-              </a:ext>
-            </a:extLst>
-          </p:cNvPr>
+          <p:cNvPr id="5" name="Slide Number Placeholder 4"/>
           <p:cNvSpPr>
             <a:spLocks noGrp="1"/>
           </p:cNvSpPr>
@@ -2060,7 +1833,7 @@
     </p:spTree>
     <p:extLst>
       <p:ext uri="{BB962C8B-B14F-4D97-AF65-F5344CB8AC3E}">
-        <p14:creationId xmlns:p14="http://schemas.microsoft.com/office/powerpoint/2010/main" val="1005336528"/>
+        <p14:creationId xmlns:p14="http://schemas.microsoft.com/office/powerpoint/2010/main" val="3038647662"/>
       </p:ext>
     </p:extLst>
   </p:cSld>
@@ -2089,13 +1862,7 @@
       </p:grpSpPr>
       <p:sp>
         <p:nvSpPr>
-          <p:cNvPr id="2" name="Date Placeholder 1">
-            <a:extLst>
-              <a:ext uri="{FF2B5EF4-FFF2-40B4-BE49-F238E27FC236}">
-                <a16:creationId xmlns:a16="http://schemas.microsoft.com/office/drawing/2014/main" id="{AD2C1F24-E0A1-45A7-8EF5-92CD9799341C}"/>
-              </a:ext>
-            </a:extLst>
-          </p:cNvPr>
+          <p:cNvPr id="2" name="Date Placeholder 1"/>
           <p:cNvSpPr>
             <a:spLocks noGrp="1"/>
           </p:cNvSpPr>
@@ -2110,7 +1877,7 @@
           <a:p>
             <a:fld id="{F5318F62-D251-40E8-A23C-F4CFE9FEAB41}" type="datetime1">
               <a:rPr lang="en-US" smtClean="0"/>
-              <a:t>3/26/2026</a:t>
+              <a:t>3/26/26</a:t>
             </a:fld>
             <a:endParaRPr lang="en-US"/>
           </a:p>
@@ -2118,13 +1885,7 @@
       </p:sp>
       <p:sp>
         <p:nvSpPr>
-          <p:cNvPr id="3" name="Footer Placeholder 2">
-            <a:extLst>
-              <a:ext uri="{FF2B5EF4-FFF2-40B4-BE49-F238E27FC236}">
-                <a16:creationId xmlns:a16="http://schemas.microsoft.com/office/drawing/2014/main" id="{3E021C19-210E-46B0-9036-5D8AECC9260C}"/>
-              </a:ext>
-            </a:extLst>
-          </p:cNvPr>
+          <p:cNvPr id="3" name="Footer Placeholder 2"/>
           <p:cNvSpPr>
             <a:spLocks noGrp="1"/>
           </p:cNvSpPr>
@@ -2143,13 +1904,7 @@
       </p:sp>
       <p:sp>
         <p:nvSpPr>
-          <p:cNvPr id="4" name="Slide Number Placeholder 3">
-            <a:extLst>
-              <a:ext uri="{FF2B5EF4-FFF2-40B4-BE49-F238E27FC236}">
-                <a16:creationId xmlns:a16="http://schemas.microsoft.com/office/drawing/2014/main" id="{1A880FEF-487E-44DF-8615-DF2210419602}"/>
-              </a:ext>
-            </a:extLst>
-          </p:cNvPr>
+          <p:cNvPr id="4" name="Slide Number Placeholder 3"/>
           <p:cNvSpPr>
             <a:spLocks noGrp="1"/>
           </p:cNvSpPr>
@@ -2173,7 +1928,7 @@
     </p:spTree>
     <p:extLst>
       <p:ext uri="{BB962C8B-B14F-4D97-AF65-F5344CB8AC3E}">
-        <p14:creationId xmlns:p14="http://schemas.microsoft.com/office/powerpoint/2010/main" val="3678605405"/>
+        <p14:creationId xmlns:p14="http://schemas.microsoft.com/office/powerpoint/2010/main" val="4276043415"/>
       </p:ext>
     </p:extLst>
   </p:cSld>
@@ -2202,13 +1957,7 @@
       </p:grpSpPr>
       <p:sp>
         <p:nvSpPr>
-          <p:cNvPr id="2" name="Title 1">
-            <a:extLst>
-              <a:ext uri="{FF2B5EF4-FFF2-40B4-BE49-F238E27FC236}">
-                <a16:creationId xmlns:a16="http://schemas.microsoft.com/office/drawing/2014/main" id="{11A568EE-74C8-43A6-90BC-2DDD965CF64A}"/>
-              </a:ext>
-            </a:extLst>
-          </p:cNvPr>
+          <p:cNvPr id="2" name="Title 1"/>
           <p:cNvSpPr>
             <a:spLocks noGrp="1"/>
           </p:cNvSpPr>
@@ -2218,15 +1967,17 @@
         </p:nvSpPr>
         <p:spPr>
           <a:xfrm>
-            <a:off x="704088" y="1069848"/>
-            <a:ext cx="4093599" cy="1316736"/>
+            <a:off x="1444671" y="798973"/>
+            <a:ext cx="2961967" cy="2406518"/>
           </a:xfrm>
         </p:spPr>
         <p:txBody>
-          <a:bodyPr anchor="b"/>
+          <a:bodyPr anchor="b">
+            <a:normAutofit/>
+          </a:bodyPr>
           <a:lstStyle>
-            <a:lvl1pPr>
-              <a:defRPr sz="3200"/>
+            <a:lvl1pPr algn="l">
+              <a:defRPr sz="2400"/>
             </a:lvl1pPr>
           </a:lstStyle>
           <a:p>
@@ -2240,13 +1991,7 @@
       </p:sp>
       <p:sp>
         <p:nvSpPr>
-          <p:cNvPr id="3" name="Content Placeholder 2">
-            <a:extLst>
-              <a:ext uri="{FF2B5EF4-FFF2-40B4-BE49-F238E27FC236}">
-                <a16:creationId xmlns:a16="http://schemas.microsoft.com/office/drawing/2014/main" id="{971C35AC-CAE3-48CF-A3E4-A075C9FDD71B}"/>
-              </a:ext>
-            </a:extLst>
-          </p:cNvPr>
+          <p:cNvPr id="3" name="Content Placeholder 2"/>
           <p:cNvSpPr>
             <a:spLocks noGrp="1"/>
           </p:cNvSpPr>
@@ -2256,41 +2001,13 @@
         </p:nvSpPr>
         <p:spPr>
           <a:xfrm>
-            <a:off x="5183188" y="1069848"/>
-            <a:ext cx="6172200" cy="4791202"/>
+            <a:off x="4730324" y="798974"/>
+            <a:ext cx="6012470" cy="4658826"/>
           </a:xfrm>
         </p:spPr>
         <p:txBody>
-          <a:bodyPr/>
-          <a:lstStyle>
-            <a:lvl1pPr>
-              <a:defRPr sz="3200"/>
-            </a:lvl1pPr>
-            <a:lvl2pPr>
-              <a:defRPr sz="2800"/>
-            </a:lvl2pPr>
-            <a:lvl3pPr>
-              <a:defRPr sz="2400"/>
-            </a:lvl3pPr>
-            <a:lvl4pPr>
-              <a:defRPr sz="2000"/>
-            </a:lvl4pPr>
-            <a:lvl5pPr>
-              <a:defRPr sz="2000"/>
-            </a:lvl5pPr>
-            <a:lvl6pPr>
-              <a:defRPr sz="2000"/>
-            </a:lvl6pPr>
-            <a:lvl7pPr>
-              <a:defRPr sz="2000"/>
-            </a:lvl7pPr>
-            <a:lvl8pPr>
-              <a:defRPr sz="2000"/>
-            </a:lvl8pPr>
-            <a:lvl9pPr>
-              <a:defRPr sz="2000"/>
-            </a:lvl9pPr>
-          </a:lstStyle>
+          <a:bodyPr anchor="ctr"/>
+          <a:lstStyle/>
           <a:p>
             <a:pPr lvl="0"/>
             <a:r>
@@ -2331,13 +2048,7 @@
       </p:sp>
       <p:sp>
         <p:nvSpPr>
-          <p:cNvPr id="4" name="Text Placeholder 3">
-            <a:extLst>
-              <a:ext uri="{FF2B5EF4-FFF2-40B4-BE49-F238E27FC236}">
-                <a16:creationId xmlns:a16="http://schemas.microsoft.com/office/drawing/2014/main" id="{2D9D03EA-5FAD-4609-A2B8-624E426847E3}"/>
-              </a:ext>
-            </a:extLst>
-          </p:cNvPr>
+          <p:cNvPr id="4" name="Text Placeholder 3"/>
           <p:cNvSpPr>
             <a:spLocks noGrp="1"/>
           </p:cNvSpPr>
@@ -2347,14 +2058,14 @@
         </p:nvSpPr>
         <p:spPr>
           <a:xfrm>
-            <a:off x="704088" y="2551176"/>
-            <a:ext cx="4093599" cy="3319272"/>
+            <a:off x="1444671" y="3205491"/>
+            <a:ext cx="2961967" cy="2248181"/>
           </a:xfrm>
         </p:spPr>
         <p:txBody>
           <a:bodyPr/>
           <a:lstStyle>
-            <a:lvl1pPr marL="0" indent="0">
+            <a:lvl1pPr marL="0" indent="0" algn="l">
               <a:buNone/>
               <a:defRPr sz="1600"/>
             </a:lvl1pPr>
@@ -2402,13 +2113,7 @@
       </p:sp>
       <p:sp>
         <p:nvSpPr>
-          <p:cNvPr id="5" name="Date Placeholder 4">
-            <a:extLst>
-              <a:ext uri="{FF2B5EF4-FFF2-40B4-BE49-F238E27FC236}">
-                <a16:creationId xmlns:a16="http://schemas.microsoft.com/office/drawing/2014/main" id="{0B58D2EA-2191-4216-B64D-067BDFE12375}"/>
-              </a:ext>
-            </a:extLst>
-          </p:cNvPr>
+          <p:cNvPr id="5" name="Date Placeholder 4"/>
           <p:cNvSpPr>
             <a:spLocks noGrp="1"/>
           </p:cNvSpPr>
@@ -2423,7 +2128,7 @@
           <a:p>
             <a:fld id="{44F76144-149E-4874-93A5-554A0357CF82}" type="datetime1">
               <a:rPr lang="en-US" smtClean="0"/>
-              <a:t>3/26/2026</a:t>
+              <a:t>3/26/26</a:t>
             </a:fld>
             <a:endParaRPr lang="en-US"/>
           </a:p>
@@ -2431,13 +2136,7 @@
       </p:sp>
       <p:sp>
         <p:nvSpPr>
-          <p:cNvPr id="6" name="Footer Placeholder 5">
-            <a:extLst>
-              <a:ext uri="{FF2B5EF4-FFF2-40B4-BE49-F238E27FC236}">
-                <a16:creationId xmlns:a16="http://schemas.microsoft.com/office/drawing/2014/main" id="{78042128-DAB4-481C-BEE6-3523E8E88BAD}"/>
-              </a:ext>
-            </a:extLst>
-          </p:cNvPr>
+          <p:cNvPr id="6" name="Footer Placeholder 5"/>
           <p:cNvSpPr>
             <a:spLocks noGrp="1"/>
           </p:cNvSpPr>
@@ -2456,13 +2155,7 @@
       </p:sp>
       <p:sp>
         <p:nvSpPr>
-          <p:cNvPr id="7" name="Slide Number Placeholder 6">
-            <a:extLst>
-              <a:ext uri="{FF2B5EF4-FFF2-40B4-BE49-F238E27FC236}">
-                <a16:creationId xmlns:a16="http://schemas.microsoft.com/office/drawing/2014/main" id="{AE50E382-C500-4A4C-A7C6-43860383AB91}"/>
-              </a:ext>
-            </a:extLst>
-          </p:cNvPr>
+          <p:cNvPr id="7" name="Slide Number Placeholder 6"/>
           <p:cNvSpPr>
             <a:spLocks noGrp="1"/>
           </p:cNvSpPr>
@@ -2486,7 +2179,7 @@
     </p:spTree>
     <p:extLst>
       <p:ext uri="{BB962C8B-B14F-4D97-AF65-F5344CB8AC3E}">
-        <p14:creationId xmlns:p14="http://schemas.microsoft.com/office/powerpoint/2010/main" val="451578220"/>
+        <p14:creationId xmlns:p14="http://schemas.microsoft.com/office/powerpoint/2010/main" val="4046713292"/>
       </p:ext>
     </p:extLst>
   </p:cSld>
@@ -2513,15 +2206,148 @@
           <a:chExt cx="0" cy="0"/>
         </a:xfrm>
       </p:grpSpPr>
-      <p:sp>
-        <p:nvSpPr>
-          <p:cNvPr id="2" name="Title 1">
-            <a:extLst>
-              <a:ext uri="{FF2B5EF4-FFF2-40B4-BE49-F238E27FC236}">
-                <a16:creationId xmlns:a16="http://schemas.microsoft.com/office/drawing/2014/main" id="{139FE98B-EACF-4251-A8AF-0D9EDD17C664}"/>
-              </a:ext>
-            </a:extLst>
-          </p:cNvPr>
+      <p:grpSp>
+        <p:nvGrpSpPr>
+          <p:cNvPr id="9" name="Group 8"/>
+          <p:cNvGrpSpPr/>
+          <p:nvPr/>
+        </p:nvGrpSpPr>
+        <p:grpSpPr>
+          <a:xfrm>
+            <a:off x="7477387" y="482170"/>
+            <a:ext cx="4074533" cy="5149101"/>
+            <a:chOff x="7477387" y="482170"/>
+            <a:chExt cx="4074533" cy="5149101"/>
+          </a:xfrm>
+        </p:grpSpPr>
+        <p:sp>
+          <p:nvSpPr>
+            <p:cNvPr id="18" name="Rectangle 17"/>
+            <p:cNvSpPr/>
+            <p:nvPr/>
+          </p:nvSpPr>
+          <p:spPr>
+            <a:xfrm>
+              <a:off x="7477387" y="482170"/>
+              <a:ext cx="4074533" cy="5149101"/>
+            </a:xfrm>
+            <a:prstGeom prst="rect">
+              <a:avLst/>
+            </a:prstGeom>
+            <a:blipFill dpi="0" rotWithShape="1">
+              <a:blip r:embed="rId2">
+                <a:alphaModFix amt="30000"/>
+              </a:blip>
+              <a:srcRect/>
+              <a:tile tx="0" ty="0" sx="100000" sy="100000" flip="none" algn="ctr"/>
+            </a:blipFill>
+            <a:ln w="76200" cmpd="sng">
+              <a:noFill/>
+              <a:miter lim="800000"/>
+            </a:ln>
+            <a:effectLst>
+              <a:outerShdw blurRad="127000" dist="228600" dir="4740000" sx="98000" sy="98000" algn="tl" rotWithShape="0">
+                <a:srgbClr val="000000">
+                  <a:alpha val="34000"/>
+                </a:srgbClr>
+              </a:outerShdw>
+            </a:effectLst>
+            <a:scene3d>
+              <a:camera prst="orthographicFront"/>
+              <a:lightRig rig="threePt" dir="t"/>
+            </a:scene3d>
+            <a:sp3d extrusionH="76200" contourW="12700" prstMaterial="matte">
+              <a:bevelT w="152400" h="50800" prst="softRound"/>
+              <a:extrusionClr>
+                <a:schemeClr val="tx2"/>
+              </a:extrusionClr>
+              <a:contourClr>
+                <a:schemeClr val="bg2"/>
+              </a:contourClr>
+            </a:sp3d>
+          </p:spPr>
+          <p:style>
+            <a:lnRef idx="1">
+              <a:schemeClr val="accent1"/>
+            </a:lnRef>
+            <a:fillRef idx="3">
+              <a:schemeClr val="accent1"/>
+            </a:fillRef>
+            <a:effectRef idx="2">
+              <a:schemeClr val="accent1"/>
+            </a:effectRef>
+            <a:fontRef idx="minor">
+              <a:schemeClr val="lt1"/>
+            </a:fontRef>
+          </p:style>
+        </p:sp>
+        <p:sp>
+          <p:nvSpPr>
+            <p:cNvPr id="19" name="Rectangle 18"/>
+            <p:cNvSpPr/>
+            <p:nvPr/>
+          </p:nvSpPr>
+          <p:spPr>
+            <a:xfrm>
+              <a:off x="7790446" y="812506"/>
+              <a:ext cx="3450289" cy="4466452"/>
+            </a:xfrm>
+            <a:prstGeom prst="rect">
+              <a:avLst/>
+            </a:prstGeom>
+            <a:gradFill>
+              <a:gsLst>
+                <a:gs pos="0">
+                  <a:srgbClr val="DADADA"/>
+                </a:gs>
+                <a:gs pos="100000">
+                  <a:srgbClr val="FFFFFE"/>
+                </a:gs>
+              </a:gsLst>
+              <a:lin ang="16200000" scaled="0"/>
+            </a:gradFill>
+            <a:ln w="38100" cmpd="sng">
+              <a:solidFill>
+                <a:schemeClr val="tx2">
+                  <a:lumMod val="25000"/>
+                </a:schemeClr>
+              </a:solidFill>
+              <a:miter lim="800000"/>
+            </a:ln>
+            <a:effectLst>
+              <a:innerShdw blurRad="63500" dist="88900" dir="14100000">
+                <a:srgbClr val="000000">
+                  <a:alpha val="30000"/>
+                </a:srgbClr>
+              </a:innerShdw>
+            </a:effectLst>
+            <a:scene3d>
+              <a:camera prst="orthographicFront"/>
+              <a:lightRig rig="threePt" dir="t"/>
+            </a:scene3d>
+            <a:sp3d>
+              <a:bevelT prst="relaxedInset"/>
+            </a:sp3d>
+          </p:spPr>
+          <p:style>
+            <a:lnRef idx="1">
+              <a:schemeClr val="accent1"/>
+            </a:lnRef>
+            <a:fillRef idx="3">
+              <a:schemeClr val="accent1"/>
+            </a:fillRef>
+            <a:effectRef idx="2">
+              <a:schemeClr val="accent1"/>
+            </a:effectRef>
+            <a:fontRef idx="minor">
+              <a:schemeClr val="lt1"/>
+            </a:fontRef>
+          </p:style>
+        </p:sp>
+      </p:grpSp>
+      <p:sp>
+        <p:nvSpPr>
+          <p:cNvPr id="2" name="Title 1"/>
           <p:cNvSpPr>
             <a:spLocks noGrp="1"/>
           </p:cNvSpPr>
@@ -2531,12 +2357,14 @@
         </p:nvSpPr>
         <p:spPr>
           <a:xfrm>
-            <a:off x="704088" y="1066800"/>
-            <a:ext cx="4103431" cy="1317523"/>
+            <a:off x="1451206" y="1129512"/>
+            <a:ext cx="5532328" cy="1922299"/>
           </a:xfrm>
         </p:spPr>
         <p:txBody>
-          <a:bodyPr anchor="b"/>
+          <a:bodyPr anchor="b">
+            <a:normAutofit/>
+          </a:bodyPr>
           <a:lstStyle>
             <a:lvl1pPr>
               <a:defRPr sz="3200"/>
@@ -2553,15 +2381,9 @@
       </p:sp>
       <p:sp>
         <p:nvSpPr>
-          <p:cNvPr id="3" name="Picture Placeholder 2">
-            <a:extLst>
-              <a:ext uri="{FF2B5EF4-FFF2-40B4-BE49-F238E27FC236}">
-                <a16:creationId xmlns:a16="http://schemas.microsoft.com/office/drawing/2014/main" id="{3905F473-761A-4002-AF70-9FF878D0139E}"/>
-              </a:ext>
-            </a:extLst>
-          </p:cNvPr>
-          <p:cNvSpPr>
-            <a:spLocks noGrp="1"/>
+          <p:cNvPr id="3" name="Picture Placeholder 2"/>
+          <p:cNvSpPr>
+            <a:spLocks noGrp="1" noChangeAspect="1"/>
           </p:cNvSpPr>
           <p:nvPr>
             <p:ph type="pic" idx="1"/>
@@ -2569,87 +2391,65 @@
         </p:nvSpPr>
         <p:spPr>
           <a:xfrm>
-            <a:off x="5183188" y="1066800"/>
-            <a:ext cx="6172200" cy="4794250"/>
+            <a:off x="8124389" y="1122542"/>
+            <a:ext cx="2791171" cy="3866327"/>
+          </a:xfrm>
+          <a:solidFill>
+            <a:schemeClr val="bg1">
+              <a:lumMod val="50000"/>
+              <a:lumOff val="50000"/>
+              <a:alpha val="80000"/>
+            </a:schemeClr>
+          </a:solidFill>
+          <a:ln w="9525" cap="sq">
+            <a:noFill/>
+            <a:miter lim="800000"/>
+          </a:ln>
+          <a:effectLst/>
+        </p:spPr>
+        <p:txBody>
+          <a:bodyPr vert="horz" lIns="91440" tIns="45720" rIns="91440" bIns="45720" rtlCol="0" anchor="t">
+            <a:normAutofit/>
+          </a:bodyPr>
+          <a:lstStyle>
+            <a:lvl1pPr>
+              <a:defRPr lang="en-US" sz="3200" dirty="0"/>
+            </a:lvl1pPr>
+          </a:lstStyle>
+          <a:p>
+            <a:pPr lvl="0" algn="ctr"/>
+            <a:r>
+              <a:rPr lang="en-US"/>
+              <a:t>Click icon to add picture</a:t>
+            </a:r>
+            <a:endParaRPr lang="en-US" dirty="0"/>
+          </a:p>
+        </p:txBody>
+      </p:sp>
+      <p:sp>
+        <p:nvSpPr>
+          <p:cNvPr id="4" name="Text Placeholder 3"/>
+          <p:cNvSpPr>
+            <a:spLocks noGrp="1"/>
+          </p:cNvSpPr>
+          <p:nvPr>
+            <p:ph type="body" sz="half" idx="2"/>
+          </p:nvPr>
+        </p:nvSpPr>
+        <p:spPr>
+          <a:xfrm>
+            <a:off x="1450329" y="3059600"/>
+            <a:ext cx="5524404" cy="2090134"/>
           </a:xfrm>
         </p:spPr>
         <p:txBody>
-          <a:bodyPr/>
+          <a:bodyPr>
+            <a:normAutofit/>
+          </a:bodyPr>
           <a:lstStyle>
-            <a:lvl1pPr marL="0" indent="0">
-              <a:buNone/>
-              <a:defRPr sz="3200"/>
-            </a:lvl1pPr>
-            <a:lvl2pPr marL="457200" indent="0">
-              <a:buNone/>
-              <a:defRPr sz="2800"/>
-            </a:lvl2pPr>
-            <a:lvl3pPr marL="914400" indent="0">
-              <a:buNone/>
-              <a:defRPr sz="2400"/>
-            </a:lvl3pPr>
-            <a:lvl4pPr marL="1371600" indent="0">
-              <a:buNone/>
-              <a:defRPr sz="2000"/>
-            </a:lvl4pPr>
-            <a:lvl5pPr marL="1828800" indent="0">
-              <a:buNone/>
-              <a:defRPr sz="2000"/>
-            </a:lvl5pPr>
-            <a:lvl6pPr marL="2286000" indent="0">
-              <a:buNone/>
-              <a:defRPr sz="2000"/>
-            </a:lvl6pPr>
-            <a:lvl7pPr marL="2743200" indent="0">
-              <a:buNone/>
-              <a:defRPr sz="2000"/>
-            </a:lvl7pPr>
-            <a:lvl8pPr marL="3200400" indent="0">
-              <a:buNone/>
-              <a:defRPr sz="2000"/>
-            </a:lvl8pPr>
-            <a:lvl9pPr marL="3657600" indent="0">
-              <a:buNone/>
-              <a:defRPr sz="2000"/>
-            </a:lvl9pPr>
-          </a:lstStyle>
-          <a:p>
-            <a:r>
-              <a:rPr lang="en-US"/>
-              <a:t>Click icon to add picture</a:t>
-            </a:r>
-            <a:endParaRPr lang="en-US" dirty="0"/>
-          </a:p>
-        </p:txBody>
-      </p:sp>
-      <p:sp>
-        <p:nvSpPr>
-          <p:cNvPr id="4" name="Text Placeholder 3">
-            <a:extLst>
-              <a:ext uri="{FF2B5EF4-FFF2-40B4-BE49-F238E27FC236}">
-                <a16:creationId xmlns:a16="http://schemas.microsoft.com/office/drawing/2014/main" id="{FA0C2E6A-F834-4540-BB00-E13CB45DC362}"/>
-              </a:ext>
-            </a:extLst>
-          </p:cNvPr>
-          <p:cNvSpPr>
-            <a:spLocks noGrp="1"/>
-          </p:cNvSpPr>
-          <p:nvPr>
-            <p:ph type="body" sz="half" idx="2"/>
-          </p:nvPr>
-        </p:nvSpPr>
-        <p:spPr>
-          <a:xfrm>
-            <a:off x="704088" y="2552700"/>
-            <a:ext cx="4103431" cy="3316288"/>
-          </a:xfrm>
-        </p:spPr>
-        <p:txBody>
-          <a:bodyPr/>
-          <a:lstStyle>
-            <a:lvl1pPr marL="0" indent="0">
-              <a:buNone/>
-              <a:defRPr sz="1600"/>
+            <a:lvl1pPr marL="0" indent="0" algn="ctr">
+              <a:buNone/>
+              <a:defRPr sz="1800"/>
             </a:lvl1pPr>
             <a:lvl2pPr marL="457200" indent="0">
               <a:buNone/>
@@ -2695,13 +2495,7 @@
       </p:sp>
       <p:sp>
         <p:nvSpPr>
-          <p:cNvPr id="5" name="Date Placeholder 4">
-            <a:extLst>
-              <a:ext uri="{FF2B5EF4-FFF2-40B4-BE49-F238E27FC236}">
-                <a16:creationId xmlns:a16="http://schemas.microsoft.com/office/drawing/2014/main" id="{F0C38EAB-AD63-415C-B263-BA1D8FBE3CB0}"/>
-              </a:ext>
-            </a:extLst>
-          </p:cNvPr>
+          <p:cNvPr id="5" name="Date Placeholder 4"/>
           <p:cNvSpPr>
             <a:spLocks noGrp="1"/>
           </p:cNvSpPr>
@@ -2709,14 +2503,23 @@
             <p:ph type="dt" sz="half" idx="10"/>
           </p:nvPr>
         </p:nvSpPr>
-        <p:spPr/>
-        <p:txBody>
-          <a:bodyPr/>
-          <a:lstStyle/>
+        <p:spPr>
+          <a:xfrm>
+            <a:off x="1447382" y="5469856"/>
+            <a:ext cx="5527351" cy="320123"/>
+          </a:xfrm>
+        </p:spPr>
+        <p:txBody>
+          <a:bodyPr/>
+          <a:lstStyle>
+            <a:lvl1pPr algn="l">
+              <a:defRPr/>
+            </a:lvl1pPr>
+          </a:lstStyle>
           <a:p>
             <a:fld id="{50BA65D8-0540-4835-AE5C-25D29DBA01BE}" type="datetime1">
               <a:rPr lang="en-US" smtClean="0"/>
-              <a:t>3/26/2026</a:t>
+              <a:t>3/26/26</a:t>
             </a:fld>
             <a:endParaRPr lang="en-US"/>
           </a:p>
@@ -2724,13 +2527,7 @@
       </p:sp>
       <p:sp>
         <p:nvSpPr>
-          <p:cNvPr id="6" name="Footer Placeholder 5">
-            <a:extLst>
-              <a:ext uri="{FF2B5EF4-FFF2-40B4-BE49-F238E27FC236}">
-                <a16:creationId xmlns:a16="http://schemas.microsoft.com/office/drawing/2014/main" id="{422E5541-B6DE-45E8-BCFE-0DFC4F574079}"/>
-              </a:ext>
-            </a:extLst>
-          </p:cNvPr>
+          <p:cNvPr id="6" name="Footer Placeholder 5"/>
           <p:cNvSpPr>
             <a:spLocks noGrp="1"/>
           </p:cNvSpPr>
@@ -2738,7 +2535,12 @@
             <p:ph type="ftr" sz="quarter" idx="11"/>
           </p:nvPr>
         </p:nvSpPr>
-        <p:spPr/>
+        <p:spPr>
+          <a:xfrm>
+            <a:off x="1447382" y="318640"/>
+            <a:ext cx="5541004" cy="320931"/>
+          </a:xfrm>
+        </p:spPr>
         <p:txBody>
           <a:bodyPr/>
           <a:lstStyle/>
@@ -2749,13 +2551,7 @@
       </p:sp>
       <p:sp>
         <p:nvSpPr>
-          <p:cNvPr id="7" name="Slide Number Placeholder 6">
-            <a:extLst>
-              <a:ext uri="{FF2B5EF4-FFF2-40B4-BE49-F238E27FC236}">
-                <a16:creationId xmlns:a16="http://schemas.microsoft.com/office/drawing/2014/main" id="{DBB78D45-289B-46AF-8CB9-E6150BEA17ED}"/>
-              </a:ext>
-            </a:extLst>
-          </p:cNvPr>
+          <p:cNvPr id="7" name="Slide Number Placeholder 6"/>
           <p:cNvSpPr>
             <a:spLocks noGrp="1"/>
           </p:cNvSpPr>
@@ -2779,7 +2575,7 @@
     </p:spTree>
     <p:extLst>
       <p:ext uri="{BB962C8B-B14F-4D97-AF65-F5344CB8AC3E}">
-        <p14:creationId xmlns:p14="http://schemas.microsoft.com/office/powerpoint/2010/main" val="33836922"/>
+        <p14:creationId xmlns:p14="http://schemas.microsoft.com/office/powerpoint/2010/main" val="2781144661"/>
       </p:ext>
     </p:extLst>
   </p:cSld>
@@ -2793,7 +2589,7 @@
 <p:sldMaster xmlns:a="http://schemas.openxmlformats.org/drawingml/2006/main" xmlns:r="http://schemas.openxmlformats.org/officeDocument/2006/relationships" xmlns:p="http://schemas.openxmlformats.org/presentationml/2006/main">
   <p:cSld>
     <p:bg>
-      <p:bgRef idx="1001">
+      <p:bgRef idx="1003">
         <a:schemeClr val="bg1"/>
       </p:bgRef>
     </p:bg>
@@ -2813,13 +2609,7 @@
       </p:grpSpPr>
       <p:sp>
         <p:nvSpPr>
-          <p:cNvPr id="2" name="Title Placeholder 1">
-            <a:extLst>
-              <a:ext uri="{FF2B5EF4-FFF2-40B4-BE49-F238E27FC236}">
-                <a16:creationId xmlns:a16="http://schemas.microsoft.com/office/drawing/2014/main" id="{47A362AC-B59F-4AC7-B279-57DDD5336BCA}"/>
-              </a:ext>
-            </a:extLst>
-          </p:cNvPr>
+          <p:cNvPr id="2" name="Title Placeholder 1"/>
           <p:cNvSpPr>
             <a:spLocks noGrp="1"/>
           </p:cNvSpPr>
@@ -2829,15 +2619,15 @@
         </p:nvSpPr>
         <p:spPr>
           <a:xfrm>
-            <a:off x="700635" y="914400"/>
-            <a:ext cx="10691265" cy="1307592"/>
+            <a:off x="1451579" y="804519"/>
+            <a:ext cx="9291215" cy="1049235"/>
           </a:xfrm>
           <a:prstGeom prst="rect">
             <a:avLst/>
           </a:prstGeom>
         </p:spPr>
         <p:txBody>
-          <a:bodyPr vert="horz" lIns="91440" tIns="45720" rIns="91440" bIns="45720" rtlCol="0" anchor="t">
+          <a:bodyPr vert="horz" lIns="91440" tIns="45720" rIns="91440" bIns="45720" rtlCol="0" anchor="ctr">
             <a:normAutofit/>
           </a:bodyPr>
           <a:lstStyle/>
@@ -2852,13 +2642,7 @@
       </p:sp>
       <p:sp>
         <p:nvSpPr>
-          <p:cNvPr id="3" name="Text Placeholder 2">
-            <a:extLst>
-              <a:ext uri="{FF2B5EF4-FFF2-40B4-BE49-F238E27FC236}">
-                <a16:creationId xmlns:a16="http://schemas.microsoft.com/office/drawing/2014/main" id="{0E6042DB-75BD-4EC1-B6D9-8A72EF940CAA}"/>
-              </a:ext>
-            </a:extLst>
-          </p:cNvPr>
+          <p:cNvPr id="3" name="Text Placeholder 2"/>
           <p:cNvSpPr>
             <a:spLocks noGrp="1"/>
           </p:cNvSpPr>
@@ -2868,8 +2652,8 @@
         </p:nvSpPr>
         <p:spPr>
           <a:xfrm>
-            <a:off x="700635" y="2221992"/>
-            <a:ext cx="10691265" cy="3739896"/>
+            <a:off x="1451579" y="2015732"/>
+            <a:ext cx="9291215" cy="3450613"/>
           </a:xfrm>
           <a:prstGeom prst="rect">
             <a:avLst/>
@@ -2920,13 +2704,7 @@
       </p:sp>
       <p:sp>
         <p:nvSpPr>
-          <p:cNvPr id="4" name="Date Placeholder 3">
-            <a:extLst>
-              <a:ext uri="{FF2B5EF4-FFF2-40B4-BE49-F238E27FC236}">
-                <a16:creationId xmlns:a16="http://schemas.microsoft.com/office/drawing/2014/main" id="{21DD1378-7C96-4079-B44C-3D86B4657596}"/>
-              </a:ext>
-            </a:extLst>
-          </p:cNvPr>
+          <p:cNvPr id="4" name="Date Placeholder 3"/>
           <p:cNvSpPr>
             <a:spLocks noGrp="1"/>
           </p:cNvSpPr>
@@ -2936,8 +2714,8 @@
         </p:nvSpPr>
         <p:spPr>
           <a:xfrm>
-            <a:off x="8369448" y="6356350"/>
-            <a:ext cx="2549564" cy="365125"/>
+            <a:off x="7242079" y="330370"/>
+            <a:ext cx="3500715" cy="309201"/>
           </a:xfrm>
           <a:prstGeom prst="rect">
             <a:avLst/>
@@ -2947,18 +2725,19 @@
           <a:bodyPr vert="horz" lIns="91440" tIns="45720" rIns="91440" bIns="45720" rtlCol="0" anchor="ctr"/>
           <a:lstStyle>
             <a:lvl1pPr algn="r">
-              <a:defRPr sz="1050">
+              <a:defRPr sz="1000">
                 <a:solidFill>
-                  <a:schemeClr val="tx1"/>
+                  <a:schemeClr val="tx1">
+                    <a:tint val="75000"/>
+                  </a:schemeClr>
                 </a:solidFill>
-                <a:latin typeface="+mj-lt"/>
               </a:defRPr>
             </a:lvl1pPr>
           </a:lstStyle>
           <a:p>
             <a:fld id="{E31BA835-12AC-4E8F-955A-EA3F4DE2791F}" type="datetime1">
               <a:rPr lang="en-US" smtClean="0"/>
-              <a:t>3/26/2026</a:t>
+              <a:t>3/26/26</a:t>
             </a:fld>
             <a:endParaRPr lang="en-US"/>
           </a:p>
@@ -2966,13 +2745,7 @@
       </p:sp>
       <p:sp>
         <p:nvSpPr>
-          <p:cNvPr id="5" name="Footer Placeholder 4">
-            <a:extLst>
-              <a:ext uri="{FF2B5EF4-FFF2-40B4-BE49-F238E27FC236}">
-                <a16:creationId xmlns:a16="http://schemas.microsoft.com/office/drawing/2014/main" id="{D19B6B78-577F-43F5-BAEE-BF72484C9850}"/>
-              </a:ext>
-            </a:extLst>
-          </p:cNvPr>
+          <p:cNvPr id="5" name="Footer Placeholder 4"/>
           <p:cNvSpPr>
             <a:spLocks noGrp="1"/>
           </p:cNvSpPr>
@@ -2982,8 +2755,8 @@
         </p:nvSpPr>
         <p:spPr>
           <a:xfrm>
-            <a:off x="704088" y="6356350"/>
-            <a:ext cx="4539727" cy="365125"/>
+            <a:off x="1451579" y="329307"/>
+            <a:ext cx="5626774" cy="309201"/>
           </a:xfrm>
           <a:prstGeom prst="rect">
             <a:avLst/>
@@ -2993,11 +2766,12 @@
           <a:bodyPr vert="horz" lIns="91440" tIns="45720" rIns="91440" bIns="45720" rtlCol="0" anchor="ctr"/>
           <a:lstStyle>
             <a:lvl1pPr algn="l">
-              <a:defRPr sz="1050">
+              <a:defRPr sz="1000">
                 <a:solidFill>
-                  <a:schemeClr val="tx1"/>
+                  <a:schemeClr val="tx1">
+                    <a:tint val="75000"/>
+                  </a:schemeClr>
                 </a:solidFill>
-                <a:latin typeface="+mj-lt"/>
               </a:defRPr>
             </a:lvl1pPr>
           </a:lstStyle>
@@ -3008,13 +2782,7 @@
       </p:sp>
       <p:sp>
         <p:nvSpPr>
-          <p:cNvPr id="6" name="Slide Number Placeholder 5">
-            <a:extLst>
-              <a:ext uri="{FF2B5EF4-FFF2-40B4-BE49-F238E27FC236}">
-                <a16:creationId xmlns:a16="http://schemas.microsoft.com/office/drawing/2014/main" id="{A8CC75B8-AF8F-4D8A-9B3D-D1951A64BADB}"/>
-              </a:ext>
-            </a:extLst>
-          </p:cNvPr>
+          <p:cNvPr id="6" name="Slide Number Placeholder 5"/>
           <p:cNvSpPr>
             <a:spLocks noGrp="1"/>
           </p:cNvSpPr>
@@ -3024,20 +2792,20 @@
         </p:nvSpPr>
         <p:spPr>
           <a:xfrm>
-            <a:off x="10919012" y="6356350"/>
-            <a:ext cx="672354" cy="365125"/>
+            <a:off x="480060" y="798973"/>
+            <a:ext cx="811019" cy="503578"/>
           </a:xfrm>
           <a:prstGeom prst="rect">
             <a:avLst/>
           </a:prstGeom>
         </p:spPr>
         <p:txBody>
-          <a:bodyPr vert="horz" lIns="91440" tIns="45720" rIns="91440" bIns="45720" rtlCol="0" anchor="ctr"/>
+          <a:bodyPr vert="horz" lIns="91440" tIns="45720" rIns="91440" bIns="45720" rtlCol="0" anchor="t"/>
           <a:lstStyle>
             <a:lvl1pPr algn="r">
-              <a:defRPr sz="1800">
+              <a:defRPr sz="2800">
                 <a:solidFill>
-                  <a:schemeClr val="tx1"/>
+                  <a:schemeClr val="accent1"/>
                 </a:solidFill>
               </a:defRPr>
             </a:lvl1pPr>
@@ -3051,74 +2819,105 @@
           </a:p>
         </p:txBody>
       </p:sp>
-      <p:cxnSp>
-        <p:nvCxnSpPr>
-          <p:cNvPr id="7" name="Straight Connector 6">
-            <a:extLst>
-              <a:ext uri="{FF2B5EF4-FFF2-40B4-BE49-F238E27FC236}">
-                <a16:creationId xmlns:a16="http://schemas.microsoft.com/office/drawing/2014/main" id="{F64F9B95-9045-48D2-B9F3-2927E98F54AA}"/>
-              </a:ext>
-            </a:extLst>
-          </p:cNvPr>
-          <p:cNvCxnSpPr>
-            <a:cxnSpLocks/>
-          </p:cNvCxnSpPr>
+      <p:sp>
+        <p:nvSpPr>
+          <p:cNvPr id="9" name="Rectangle 8"/>
+          <p:cNvSpPr/>
           <p:nvPr/>
-        </p:nvCxnSpPr>
+        </p:nvSpPr>
         <p:spPr>
           <a:xfrm>
-            <a:off x="800100" y="723900"/>
-            <a:ext cx="10591800" cy="0"/>
+            <a:off x="0" y="3622291"/>
+            <a:ext cx="12192000" cy="2505984"/>
           </a:xfrm>
-          <a:prstGeom prst="line">
+          <a:prstGeom prst="rect">
             <a:avLst/>
           </a:prstGeom>
-          <a:ln w="44450">
-            <a:solidFill>
-              <a:schemeClr val="tx1"/>
-            </a:solidFill>
+          <a:gradFill flip="none" rotWithShape="1">
+            <a:gsLst>
+              <a:gs pos="0">
+                <a:schemeClr val="bg2">
+                  <a:alpha val="0"/>
+                </a:schemeClr>
+              </a:gs>
+              <a:gs pos="100000">
+                <a:schemeClr val="bg2">
+                  <a:alpha val="80000"/>
+                </a:schemeClr>
+              </a:gs>
+            </a:gsLst>
+            <a:lin ang="5400000" scaled="0"/>
+            <a:tileRect/>
+          </a:gradFill>
+          <a:ln>
+            <a:noFill/>
           </a:ln>
         </p:spPr>
         <p:style>
-          <a:lnRef idx="1">
-            <a:schemeClr val="accent1"/>
+          <a:lnRef idx="2">
+            <a:schemeClr val="accent1">
+              <a:shade val="50000"/>
+            </a:schemeClr>
           </a:lnRef>
-          <a:fillRef idx="0">
+          <a:fillRef idx="1">
             <a:schemeClr val="accent1"/>
           </a:fillRef>
           <a:effectRef idx="0">
             <a:schemeClr val="accent1"/>
           </a:effectRef>
           <a:fontRef idx="minor">
-            <a:schemeClr val="tx1"/>
+            <a:schemeClr val="lt1"/>
           </a:fontRef>
         </p:style>
-      </p:cxnSp>
+      </p:sp>
+      <p:pic>
+        <p:nvPicPr>
+          <p:cNvPr id="10" name="Picture 9"/>
+          <p:cNvPicPr>
+            <a:picLocks noChangeAspect="1"/>
+          </p:cNvPicPr>
+          <p:nvPr/>
+        </p:nvPicPr>
+        <p:blipFill rotWithShape="1">
+          <a:blip r:embed="rId13">
+            <a:extLst>
+              <a:ext uri="{28A0092B-C50C-407E-A947-70E740481C1C}">
+                <a14:useLocalDpi xmlns:a14="http://schemas.microsoft.com/office/drawing/2010/main" val="0"/>
+              </a:ext>
+            </a:extLst>
+          </a:blip>
+          <a:srcRect t="1538" b="-1538"/>
+          <a:stretch/>
+        </p:blipFill>
+        <p:spPr>
+          <a:xfrm>
+            <a:off x="0" y="6129338"/>
+            <a:ext cx="12192000" cy="742950"/>
+          </a:xfrm>
+          <a:prstGeom prst="rect">
+            <a:avLst/>
+          </a:prstGeom>
+        </p:spPr>
+      </p:pic>
       <p:cxnSp>
         <p:nvCxnSpPr>
-          <p:cNvPr id="8" name="Straight Connector 7">
-            <a:extLst>
-              <a:ext uri="{FF2B5EF4-FFF2-40B4-BE49-F238E27FC236}">
-                <a16:creationId xmlns:a16="http://schemas.microsoft.com/office/drawing/2014/main" id="{085AA86F-6A4D-4BCB-A045-D992CDC2959B}"/>
-              </a:ext>
-            </a:extLst>
-          </p:cNvPr>
-          <p:cNvCxnSpPr>
-            <a:cxnSpLocks/>
-          </p:cNvCxnSpPr>
+          <p:cNvPr id="12" name="Straight Connector 11"/>
+          <p:cNvCxnSpPr/>
           <p:nvPr/>
         </p:nvCxnSpPr>
         <p:spPr>
           <a:xfrm>
-            <a:off x="800100" y="6142781"/>
-            <a:ext cx="10591800" cy="0"/>
+            <a:off x="0" y="6138142"/>
+            <a:ext cx="12192000" cy="0"/>
           </a:xfrm>
           <a:prstGeom prst="line">
             <a:avLst/>
           </a:prstGeom>
           <a:ln w="12700">
             <a:solidFill>
-              <a:schemeClr val="tx1"/>
+              <a:srgbClr val="000001">
+                <a:alpha val="20000"/>
+              </a:srgbClr>
             </a:solidFill>
           </a:ln>
         </p:spPr>
@@ -3140,39 +2939,40 @@
     </p:spTree>
     <p:extLst>
       <p:ext uri="{BB962C8B-B14F-4D97-AF65-F5344CB8AC3E}">
-        <p14:creationId xmlns:p14="http://schemas.microsoft.com/office/powerpoint/2010/main" val="2694262947"/>
+        <p14:creationId xmlns:p14="http://schemas.microsoft.com/office/powerpoint/2010/main" val="4036706271"/>
       </p:ext>
     </p:extLst>
   </p:cSld>
-  <p:clrMap bg1="lt1" tx1="dk1" bg2="lt2" tx2="dk2" accent1="accent1" accent2="accent2" accent3="accent3" accent4="accent4" accent5="accent5" accent6="accent6" hlink="hlink" folHlink="folHlink"/>
+  <p:clrMap bg1="dk1" tx1="lt1" bg2="dk2" tx2="lt2" accent1="accent1" accent2="accent2" accent3="accent3" accent4="accent4" accent5="accent5" accent6="accent6" hlink="hlink" folHlink="folHlink"/>
   <p:sldLayoutIdLst>
-    <p:sldLayoutId id="2147483675" r:id="rId1"/>
-    <p:sldLayoutId id="2147483676" r:id="rId2"/>
-    <p:sldLayoutId id="2147483677" r:id="rId3"/>
-    <p:sldLayoutId id="2147483678" r:id="rId4"/>
-    <p:sldLayoutId id="2147483679" r:id="rId5"/>
-    <p:sldLayoutId id="2147483685" r:id="rId6"/>
-    <p:sldLayoutId id="2147483680" r:id="rId7"/>
-    <p:sldLayoutId id="2147483681" r:id="rId8"/>
-    <p:sldLayoutId id="2147483682" r:id="rId9"/>
-    <p:sldLayoutId id="2147483684" r:id="rId10"/>
-    <p:sldLayoutId id="2147483683" r:id="rId11"/>
+    <p:sldLayoutId id="2147483844" r:id="rId1"/>
+    <p:sldLayoutId id="2147483845" r:id="rId2"/>
+    <p:sldLayoutId id="2147483846" r:id="rId3"/>
+    <p:sldLayoutId id="2147483847" r:id="rId4"/>
+    <p:sldLayoutId id="2147483848" r:id="rId5"/>
+    <p:sldLayoutId id="2147483849" r:id="rId6"/>
+    <p:sldLayoutId id="2147483850" r:id="rId7"/>
+    <p:sldLayoutId id="2147483851" r:id="rId8"/>
+    <p:sldLayoutId id="2147483852" r:id="rId9"/>
+    <p:sldLayoutId id="2147483853" r:id="rId10"/>
+    <p:sldLayoutId id="2147483854" r:id="rId11"/>
   </p:sldLayoutIdLst>
   <p:hf sldNum="0" hdr="0" ftr="0" dt="0"/>
   <p:txStyles>
     <p:titleStyle>
-      <a:lvl1pPr algn="l" defTabSz="914400" rtl="0" eaLnBrk="1" latinLnBrk="0" hangingPunct="1">
+      <a:lvl1pPr algn="ctr" defTabSz="914400" rtl="0" eaLnBrk="1" latinLnBrk="0" hangingPunct="1">
         <a:lnSpc>
-          <a:spcPct val="100000"/>
+          <a:spcPct val="90000"/>
         </a:lnSpc>
         <a:spcBef>
           <a:spcPct val="0"/>
         </a:spcBef>
         <a:buNone/>
-        <a:defRPr sz="4000" kern="1200" cap="all" spc="30" baseline="0">
+        <a:defRPr sz="3200" b="0" i="0" kern="1200" cap="all">
           <a:solidFill>
-            <a:schemeClr val="tx1"/>
+            <a:schemeClr val="accent1"/>
           </a:solidFill>
+          <a:effectLst/>
           <a:latin typeface="+mj-lt"/>
           <a:ea typeface="+mj-ea"/>
           <a:cs typeface="+mj-cs"/>
@@ -3182,17 +2982,22 @@
     <p:bodyStyle>
       <a:lvl1pPr marL="228600" indent="-228600" algn="l" defTabSz="914400" rtl="0" eaLnBrk="1" latinLnBrk="0" hangingPunct="1">
         <a:lnSpc>
-          <a:spcPct val="110000"/>
+          <a:spcPct val="120000"/>
         </a:lnSpc>
         <a:spcBef>
           <a:spcPts val="1000"/>
         </a:spcBef>
+        <a:buClr>
+          <a:schemeClr val="accent1"/>
+        </a:buClr>
+        <a:buSzPct val="100000"/>
         <a:buFont typeface="Arial" panose="020B0604020202020204" pitchFamily="34" charset="0"/>
         <a:buChar char="•"/>
         <a:defRPr sz="2000" kern="1200">
           <a:solidFill>
             <a:schemeClr val="tx1"/>
           </a:solidFill>
+          <a:effectLst/>
           <a:latin typeface="+mn-lt"/>
           <a:ea typeface="+mn-ea"/>
           <a:cs typeface="+mn-cs"/>
@@ -3200,17 +3005,22 @@
       </a:lvl1pPr>
       <a:lvl2pPr marL="685800" indent="-228600" algn="l" defTabSz="914400" rtl="0" eaLnBrk="1" latinLnBrk="0" hangingPunct="1">
         <a:lnSpc>
-          <a:spcPct val="110000"/>
+          <a:spcPct val="120000"/>
         </a:lnSpc>
         <a:spcBef>
           <a:spcPts val="500"/>
         </a:spcBef>
+        <a:buClr>
+          <a:schemeClr val="accent1"/>
+        </a:buClr>
+        <a:buSzPct val="100000"/>
         <a:buFont typeface="Arial" panose="020B0604020202020204" pitchFamily="34" charset="0"/>
         <a:buChar char="•"/>
-        <a:defRPr sz="1800" kern="1200">
+        <a:defRPr sz="1800" kern="1200" cap="none" baseline="0">
           <a:solidFill>
             <a:schemeClr val="tx1"/>
           </a:solidFill>
+          <a:effectLst/>
           <a:latin typeface="+mn-lt"/>
           <a:ea typeface="+mn-ea"/>
           <a:cs typeface="+mn-cs"/>
@@ -3218,17 +3028,22 @@
       </a:lvl2pPr>
       <a:lvl3pPr marL="1143000" indent="-228600" algn="l" defTabSz="914400" rtl="0" eaLnBrk="1" latinLnBrk="0" hangingPunct="1">
         <a:lnSpc>
-          <a:spcPct val="110000"/>
+          <a:spcPct val="120000"/>
         </a:lnSpc>
         <a:spcBef>
           <a:spcPts val="500"/>
         </a:spcBef>
+        <a:buClr>
+          <a:schemeClr val="accent1"/>
+        </a:buClr>
+        <a:buSzPct val="100000"/>
         <a:buFont typeface="Arial" panose="020B0604020202020204" pitchFamily="34" charset="0"/>
         <a:buChar char="•"/>
         <a:defRPr sz="1600" kern="1200">
           <a:solidFill>
             <a:schemeClr val="tx1"/>
           </a:solidFill>
+          <a:effectLst/>
           <a:latin typeface="+mn-lt"/>
           <a:ea typeface="+mn-ea"/>
           <a:cs typeface="+mn-cs"/>
@@ -3236,17 +3051,22 @@
       </a:lvl3pPr>
       <a:lvl4pPr marL="1600200" indent="-228600" algn="l" defTabSz="914400" rtl="0" eaLnBrk="1" latinLnBrk="0" hangingPunct="1">
         <a:lnSpc>
-          <a:spcPct val="110000"/>
+          <a:spcPct val="120000"/>
         </a:lnSpc>
         <a:spcBef>
           <a:spcPts val="500"/>
         </a:spcBef>
+        <a:buClr>
+          <a:schemeClr val="accent1"/>
+        </a:buClr>
+        <a:buSzPct val="100000"/>
         <a:buFont typeface="Arial" panose="020B0604020202020204" pitchFamily="34" charset="0"/>
         <a:buChar char="•"/>
-        <a:defRPr sz="1400" kern="1200">
+        <a:defRPr sz="1400" kern="1200" cap="none" baseline="0">
           <a:solidFill>
             <a:schemeClr val="tx1"/>
           </a:solidFill>
+          <a:effectLst/>
           <a:latin typeface="+mn-lt"/>
           <a:ea typeface="+mn-ea"/>
           <a:cs typeface="+mn-cs"/>
@@ -3254,17 +3074,22 @@
       </a:lvl4pPr>
       <a:lvl5pPr marL="2057400" indent="-228600" algn="l" defTabSz="914400" rtl="0" eaLnBrk="1" latinLnBrk="0" hangingPunct="1">
         <a:lnSpc>
-          <a:spcPct val="110000"/>
+          <a:spcPct val="120000"/>
         </a:lnSpc>
         <a:spcBef>
           <a:spcPts val="500"/>
         </a:spcBef>
+        <a:buClr>
+          <a:schemeClr val="accent1"/>
+        </a:buClr>
+        <a:buSzPct val="100000"/>
         <a:buFont typeface="Arial" panose="020B0604020202020204" pitchFamily="34" charset="0"/>
         <a:buChar char="•"/>
-        <a:defRPr sz="1400" kern="1200">
+        <a:defRPr sz="1200" kern="1200">
           <a:solidFill>
             <a:schemeClr val="tx1"/>
           </a:solidFill>
+          <a:effectLst/>
           <a:latin typeface="+mn-lt"/>
           <a:ea typeface="+mn-ea"/>
           <a:cs typeface="+mn-cs"/>
@@ -3272,17 +3097,22 @@
       </a:lvl5pPr>
       <a:lvl6pPr marL="2514600" indent="-228600" algn="l" defTabSz="914400" rtl="0" eaLnBrk="1" latinLnBrk="0" hangingPunct="1">
         <a:lnSpc>
-          <a:spcPct val="90000"/>
+          <a:spcPct val="120000"/>
         </a:lnSpc>
         <a:spcBef>
           <a:spcPts val="500"/>
         </a:spcBef>
+        <a:buClr>
+          <a:schemeClr val="accent1"/>
+        </a:buClr>
+        <a:buSzPct val="100000"/>
         <a:buFont typeface="Arial" panose="020B0604020202020204" pitchFamily="34" charset="0"/>
         <a:buChar char="•"/>
-        <a:defRPr sz="1800" kern="1200">
+        <a:defRPr sz="1200" kern="1200">
           <a:solidFill>
             <a:schemeClr val="tx1"/>
           </a:solidFill>
+          <a:effectLst/>
           <a:latin typeface="+mn-lt"/>
           <a:ea typeface="+mn-ea"/>
           <a:cs typeface="+mn-cs"/>
@@ -3290,17 +3120,22 @@
       </a:lvl6pPr>
       <a:lvl7pPr marL="2971800" indent="-228600" algn="l" defTabSz="914400" rtl="0" eaLnBrk="1" latinLnBrk="0" hangingPunct="1">
         <a:lnSpc>
-          <a:spcPct val="90000"/>
+          <a:spcPct val="120000"/>
         </a:lnSpc>
         <a:spcBef>
           <a:spcPts val="500"/>
         </a:spcBef>
+        <a:buClr>
+          <a:schemeClr val="accent1"/>
+        </a:buClr>
+        <a:buSzPct val="100000"/>
         <a:buFont typeface="Arial" panose="020B0604020202020204" pitchFamily="34" charset="0"/>
         <a:buChar char="•"/>
-        <a:defRPr sz="1800" kern="1200">
+        <a:defRPr sz="1200" kern="1200">
           <a:solidFill>
             <a:schemeClr val="tx1"/>
           </a:solidFill>
+          <a:effectLst/>
           <a:latin typeface="+mn-lt"/>
           <a:ea typeface="+mn-ea"/>
           <a:cs typeface="+mn-cs"/>
@@ -3308,17 +3143,22 @@
       </a:lvl7pPr>
       <a:lvl8pPr marL="3429000" indent="-228600" algn="l" defTabSz="914400" rtl="0" eaLnBrk="1" latinLnBrk="0" hangingPunct="1">
         <a:lnSpc>
-          <a:spcPct val="90000"/>
+          <a:spcPct val="120000"/>
         </a:lnSpc>
         <a:spcBef>
           <a:spcPts val="500"/>
         </a:spcBef>
+        <a:buClr>
+          <a:schemeClr val="accent1"/>
+        </a:buClr>
+        <a:buSzPct val="100000"/>
         <a:buFont typeface="Arial" panose="020B0604020202020204" pitchFamily="34" charset="0"/>
         <a:buChar char="•"/>
-        <a:defRPr sz="1800" kern="1200">
+        <a:defRPr sz="1200" kern="1200" baseline="0">
           <a:solidFill>
             <a:schemeClr val="tx1"/>
           </a:solidFill>
+          <a:effectLst/>
           <a:latin typeface="+mn-lt"/>
           <a:ea typeface="+mn-ea"/>
           <a:cs typeface="+mn-cs"/>
@@ -3326,17 +3166,22 @@
       </a:lvl8pPr>
       <a:lvl9pPr marL="3886200" indent="-228600" algn="l" defTabSz="914400" rtl="0" eaLnBrk="1" latinLnBrk="0" hangingPunct="1">
         <a:lnSpc>
-          <a:spcPct val="90000"/>
+          <a:spcPct val="120000"/>
         </a:lnSpc>
         <a:spcBef>
           <a:spcPts val="500"/>
         </a:spcBef>
+        <a:buClr>
+          <a:schemeClr val="accent1"/>
+        </a:buClr>
+        <a:buSzPct val="100000"/>
         <a:buFont typeface="Arial" panose="020B0604020202020204" pitchFamily="34" charset="0"/>
         <a:buChar char="•"/>
-        <a:defRPr sz="1800" kern="1200">
+        <a:defRPr sz="1200" kern="1200" baseline="0">
           <a:solidFill>
             <a:schemeClr val="tx1"/>
           </a:solidFill>
+          <a:effectLst/>
           <a:latin typeface="+mn-lt"/>
           <a:ea typeface="+mn-ea"/>
           <a:cs typeface="+mn-cs"/>
@@ -3447,9 +3292,25 @@
   <p:cSld>
     <p:bg>
       <p:bgPr>
-        <a:solidFill>
-          <a:schemeClr val="bg1"/>
-        </a:solidFill>
+        <a:gradFill rotWithShape="1">
+          <a:gsLst>
+            <a:gs pos="0">
+              <a:schemeClr val="bg1">
+                <a:tint val="94000"/>
+                <a:satMod val="80000"/>
+                <a:lumMod val="106000"/>
+              </a:schemeClr>
+            </a:gs>
+            <a:gs pos="100000">
+              <a:schemeClr val="bg1">
+                <a:shade val="80000"/>
+              </a:schemeClr>
+            </a:gs>
+          </a:gsLst>
+          <a:path path="circle">
+            <a:fillToRect l="43000" r="43000" b="100000"/>
+          </a:path>
+        </a:gradFill>
         <a:effectLst/>
       </p:bgPr>
     </p:bg>
@@ -3467,203 +3328,6 @@
           <a:chExt cx="0" cy="0"/>
         </a:xfrm>
       </p:grpSpPr>
-      <p:sp useBgFill="1">
-        <p:nvSpPr>
-          <p:cNvPr id="9" name="Rectangle 8">
-            <a:extLst>
-              <a:ext uri="{FF2B5EF4-FFF2-40B4-BE49-F238E27FC236}">
-                <a16:creationId xmlns:a16="http://schemas.microsoft.com/office/drawing/2014/main" id="{85CB65D0-496F-4797-A015-C85839E35D1A}"/>
-              </a:ext>
-              <a:ext uri="{C183D7F6-B498-43B3-948B-1728B52AA6E4}">
-                <adec:decorative xmlns:adec="http://schemas.microsoft.com/office/drawing/2017/decorative" val="1"/>
-              </a:ext>
-            </a:extLst>
-          </p:cNvPr>
-          <p:cNvSpPr>
-            <a:spLocks noGrp="1" noRot="1" noChangeAspect="1" noMove="1" noResize="1" noEditPoints="1" noAdjustHandles="1" noChangeArrowheads="1" noChangeShapeType="1" noTextEdit="1"/>
-          </p:cNvSpPr>
-          <p:nvPr>
-            <p:extLst>
-              <p:ext uri="{386F3935-93C4-4BCD-93E2-E3B085C9AB24}">
-                <p16:designElem xmlns:p16="http://schemas.microsoft.com/office/powerpoint/2015/main" val="1"/>
-              </p:ext>
-            </p:extLst>
-          </p:nvPr>
-        </p:nvSpPr>
-        <p:spPr>
-          <a:xfrm>
-            <a:off x="0" y="0"/>
-            <a:ext cx="12192000" cy="6858000"/>
-          </a:xfrm>
-          <a:prstGeom prst="rect">
-            <a:avLst/>
-          </a:prstGeom>
-          <a:ln w="12700" cap="flat" cmpd="sng" algn="ctr">
-            <a:noFill/>
-            <a:prstDash val="solid"/>
-            <a:miter lim="800000"/>
-          </a:ln>
-          <a:effectLst/>
-          <a:extLst>
-            <a:ext uri="{91240B29-F687-4F45-9708-019B960494DF}">
-              <a14:hiddenLine xmlns:a14="http://schemas.microsoft.com/office/drawing/2010/main" w="12700" cap="flat" cmpd="sng" algn="ctr">
-                <a:solidFill>
-                  <a:schemeClr val="accent1">
-                    <a:shade val="50000"/>
-                  </a:schemeClr>
-                </a:solidFill>
-                <a:prstDash val="solid"/>
-                <a:miter lim="800000"/>
-              </a14:hiddenLine>
-            </a:ext>
-          </a:extLst>
-        </p:spPr>
-        <p:style>
-          <a:lnRef idx="2">
-            <a:schemeClr val="accent1">
-              <a:shade val="50000"/>
-            </a:schemeClr>
-          </a:lnRef>
-          <a:fillRef idx="1">
-            <a:schemeClr val="accent1"/>
-          </a:fillRef>
-          <a:effectRef idx="0">
-            <a:schemeClr val="accent1"/>
-          </a:effectRef>
-          <a:fontRef idx="minor">
-            <a:schemeClr val="lt1"/>
-          </a:fontRef>
-        </p:style>
-        <p:txBody>
-          <a:bodyPr rtlCol="0" anchor="ctr"/>
-          <a:lstStyle/>
-          <a:p>
-            <a:pPr algn="ctr"/>
-            <a:endParaRPr lang="en-US"/>
-          </a:p>
-        </p:txBody>
-      </p:sp>
-      <p:pic>
-        <p:nvPicPr>
-          <p:cNvPr id="4" name="Picture 3">
-            <a:extLst>
-              <a:ext uri="{FF2B5EF4-FFF2-40B4-BE49-F238E27FC236}">
-                <a16:creationId xmlns:a16="http://schemas.microsoft.com/office/drawing/2014/main" id="{1008BDD7-A5CE-321B-DC80-98033147637E}"/>
-              </a:ext>
-            </a:extLst>
-          </p:cNvPr>
-          <p:cNvPicPr>
-            <a:picLocks noChangeAspect="1"/>
-          </p:cNvPicPr>
-          <p:nvPr/>
-        </p:nvPicPr>
-        <p:blipFill>
-          <a:blip r:embed="rId2"/>
-          <a:srcRect b="25000"/>
-          <a:stretch>
-            <a:fillRect/>
-          </a:stretch>
-        </p:blipFill>
-        <p:spPr>
-          <a:xfrm>
-            <a:off x="1" y="10"/>
-            <a:ext cx="12192000" cy="6857989"/>
-          </a:xfrm>
-          <a:prstGeom prst="rect">
-            <a:avLst/>
-          </a:prstGeom>
-        </p:spPr>
-      </p:pic>
-      <p:sp>
-        <p:nvSpPr>
-          <p:cNvPr id="11" name="Rectangle 10">
-            <a:extLst>
-              <a:ext uri="{FF2B5EF4-FFF2-40B4-BE49-F238E27FC236}">
-                <a16:creationId xmlns:a16="http://schemas.microsoft.com/office/drawing/2014/main" id="{95D2C779-8883-4E5F-A170-0F464918C1B7}"/>
-              </a:ext>
-              <a:ext uri="{C183D7F6-B498-43B3-948B-1728B52AA6E4}">
-                <adec:decorative xmlns:adec="http://schemas.microsoft.com/office/drawing/2017/decorative" val="1"/>
-              </a:ext>
-            </a:extLst>
-          </p:cNvPr>
-          <p:cNvSpPr>
-            <a:spLocks noGrp="1" noRot="1" noChangeAspect="1" noMove="1" noResize="1" noEditPoints="1" noAdjustHandles="1" noChangeArrowheads="1" noChangeShapeType="1" noTextEdit="1"/>
-          </p:cNvSpPr>
-          <p:nvPr>
-            <p:extLst>
-              <p:ext uri="{386F3935-93C4-4BCD-93E2-E3B085C9AB24}">
-                <p16:designElem xmlns:p16="http://schemas.microsoft.com/office/powerpoint/2015/main" val="1"/>
-              </p:ext>
-            </p:extLst>
-          </p:nvPr>
-        </p:nvSpPr>
-        <p:spPr>
-          <a:xfrm rot="10800000">
-            <a:off x="-2307" y="990598"/>
-            <a:ext cx="12188952" cy="4745182"/>
-          </a:xfrm>
-          <a:prstGeom prst="rect">
-            <a:avLst/>
-          </a:prstGeom>
-          <a:gradFill>
-            <a:gsLst>
-              <a:gs pos="35000">
-                <a:srgbClr val="000000">
-                  <a:alpha val="41000"/>
-                </a:srgbClr>
-              </a:gs>
-              <a:gs pos="0">
-                <a:srgbClr val="000000">
-                  <a:alpha val="0"/>
-                </a:srgbClr>
-              </a:gs>
-              <a:gs pos="47744">
-                <a:srgbClr val="000000">
-                  <a:alpha val="51000"/>
-                </a:srgbClr>
-              </a:gs>
-              <a:gs pos="70000">
-                <a:srgbClr val="000000">
-                  <a:alpha val="37000"/>
-                </a:srgbClr>
-              </a:gs>
-              <a:gs pos="100000">
-                <a:srgbClr val="000000">
-                  <a:alpha val="0"/>
-                </a:srgbClr>
-              </a:gs>
-            </a:gsLst>
-            <a:lin ang="5400000" scaled="1"/>
-          </a:gradFill>
-          <a:ln>
-            <a:noFill/>
-          </a:ln>
-        </p:spPr>
-        <p:style>
-          <a:lnRef idx="2">
-            <a:schemeClr val="accent1">
-              <a:shade val="50000"/>
-            </a:schemeClr>
-          </a:lnRef>
-          <a:fillRef idx="1">
-            <a:schemeClr val="accent1"/>
-          </a:fillRef>
-          <a:effectRef idx="0">
-            <a:schemeClr val="accent1"/>
-          </a:effectRef>
-          <a:fontRef idx="minor">
-            <a:schemeClr val="lt1"/>
-          </a:fontRef>
-        </p:style>
-        <p:txBody>
-          <a:bodyPr rtlCol="0" anchor="ctr"/>
-          <a:lstStyle/>
-          <a:p>
-            <a:pPr algn="ctr"/>
-            <a:endParaRPr lang="en-US"/>
-          </a:p>
-        </p:txBody>
-      </p:sp>
       <p:sp>
         <p:nvSpPr>
           <p:cNvPr id="2" name="Title 1">
@@ -3682,23 +3346,18 @@
         </p:nvSpPr>
         <p:spPr>
           <a:xfrm>
-            <a:off x="1833541" y="990599"/>
-            <a:ext cx="5619054" cy="4849091"/>
+            <a:off x="1452617" y="963699"/>
+            <a:ext cx="4960388" cy="2470307"/>
           </a:xfrm>
         </p:spPr>
         <p:txBody>
-          <a:bodyPr anchor="ctr">
+          <a:bodyPr>
             <a:normAutofit/>
           </a:bodyPr>
           <a:lstStyle/>
           <a:p>
-            <a:pPr algn="r"/>
-            <a:r>
-              <a:rPr lang="en-US" dirty="0">
-                <a:solidFill>
-                  <a:srgbClr val="FFFFFF"/>
-                </a:solidFill>
-              </a:rPr>
+            <a:r>
+              <a:rPr lang="en-US" sz="5400"/>
               <a:t>Garden Clicker</a:t>
             </a:r>
           </a:p>
@@ -3722,42 +3381,38 @@
         </p:nvSpPr>
         <p:spPr>
           <a:xfrm>
-            <a:off x="8712865" y="1447799"/>
-            <a:ext cx="2368905" cy="4076699"/>
+            <a:off x="1452617" y="3448294"/>
+            <a:ext cx="4960388" cy="1693553"/>
           </a:xfrm>
         </p:spPr>
         <p:txBody>
-          <a:bodyPr anchor="ctr">
+          <a:bodyPr>
             <a:normAutofit/>
           </a:bodyPr>
           <a:lstStyle/>
           <a:p>
             <a:r>
-              <a:rPr lang="en-US">
-                <a:solidFill>
-                  <a:srgbClr val="FFFFFF"/>
-                </a:solidFill>
-              </a:rPr>
+              <a:rPr lang="en-US"/>
               <a:t>By: Oliver D’Avino &amp; Kiara Bartuccio</a:t>
             </a:r>
           </a:p>
         </p:txBody>
       </p:sp>
-      <p:cxnSp>
-        <p:nvCxnSpPr>
-          <p:cNvPr id="13" name="Straight Connector 12">
+      <p:grpSp>
+        <p:nvGrpSpPr>
+          <p:cNvPr id="1031" name="Group 1030">
             <a:extLst>
               <a:ext uri="{FF2B5EF4-FFF2-40B4-BE49-F238E27FC236}">
-                <a16:creationId xmlns:a16="http://schemas.microsoft.com/office/drawing/2014/main" id="{BD96A694-258D-4418-A83C-B9BA72FD44B8}"/>
+                <a16:creationId xmlns:a16="http://schemas.microsoft.com/office/drawing/2014/main" id="{B1B8B780-99C4-4D1C-A595-95814562E377}"/>
               </a:ext>
               <a:ext uri="{C183D7F6-B498-43B3-948B-1728B52AA6E4}">
                 <adec:decorative xmlns:adec="http://schemas.microsoft.com/office/drawing/2017/decorative" val="1"/>
               </a:ext>
             </a:extLst>
           </p:cNvPr>
-          <p:cNvCxnSpPr>
-            <a:cxnSpLocks noGrp="1" noRot="1" noChangeAspect="1" noMove="1" noResize="1" noEditPoints="1" noAdjustHandles="1" noChangeArrowheads="1" noChangeShapeType="1"/>
-          </p:cNvCxnSpPr>
+          <p:cNvGrpSpPr>
+            <a:grpSpLocks noGrp="1" noUngrp="1" noRot="1" noChangeAspect="1" noMove="1" noResize="1"/>
+          </p:cNvGrpSpPr>
           <p:nvPr>
             <p:extLst>
               <p:ext uri="{386F3935-93C4-4BCD-93E2-E3B085C9AB24}">
@@ -3765,43 +3420,233 @@
               </p:ext>
             </p:extLst>
           </p:nvPr>
-        </p:nvCxnSpPr>
-        <p:spPr>
-          <a:xfrm flipV="1">
-            <a:off x="8115300" y="1780927"/>
-            <a:ext cx="0" cy="3390901"/>
+        </p:nvGrpSpPr>
+        <p:grpSpPr>
+          <a:xfrm>
+            <a:off x="6899254" y="482171"/>
+            <a:ext cx="4652668" cy="5149101"/>
+            <a:chOff x="6899254" y="482171"/>
+            <a:chExt cx="4652668" cy="5149101"/>
           </a:xfrm>
-          <a:prstGeom prst="line">
+        </p:grpSpPr>
+        <p:sp>
+          <p:nvSpPr>
+            <p:cNvPr id="1032" name="Rectangle 1031">
+              <a:extLst>
+                <a:ext uri="{FF2B5EF4-FFF2-40B4-BE49-F238E27FC236}">
+                  <a16:creationId xmlns:a16="http://schemas.microsoft.com/office/drawing/2014/main" id="{BA9ECF46-35B4-46C2-90A2-4139C2363977}"/>
+                </a:ext>
+                <a:ext uri="{C183D7F6-B498-43B3-948B-1728B52AA6E4}">
+                  <adec:decorative xmlns:adec="http://schemas.microsoft.com/office/drawing/2017/decorative" val="1"/>
+                </a:ext>
+              </a:extLst>
+            </p:cNvPr>
+            <p:cNvSpPr/>
+            <p:nvPr>
+              <p:extLst>
+                <p:ext uri="{386F3935-93C4-4BCD-93E2-E3B085C9AB24}">
+                  <p16:designElem xmlns:p16="http://schemas.microsoft.com/office/powerpoint/2015/main" val="1"/>
+                </p:ext>
+              </p:extLst>
+            </p:nvPr>
+          </p:nvSpPr>
+          <p:spPr>
+            <a:xfrm>
+              <a:off x="6899254" y="482171"/>
+              <a:ext cx="4652668" cy="5149101"/>
+            </a:xfrm>
+            <a:prstGeom prst="rect">
+              <a:avLst/>
+            </a:prstGeom>
+            <a:blipFill dpi="0" rotWithShape="1">
+              <a:blip r:embed="rId2">
+                <a:alphaModFix amt="30000"/>
+              </a:blip>
+              <a:srcRect/>
+              <a:tile tx="0" ty="0" sx="100000" sy="100000" flip="none" algn="ctr"/>
+            </a:blipFill>
+            <a:ln w="76200" cmpd="sng">
+              <a:noFill/>
+              <a:miter lim="800000"/>
+            </a:ln>
+            <a:effectLst>
+              <a:outerShdw blurRad="127000" dist="228600" dir="4740000" sx="98000" sy="98000" algn="tl" rotWithShape="0">
+                <a:srgbClr val="000000">
+                  <a:alpha val="34000"/>
+                </a:srgbClr>
+              </a:outerShdw>
+            </a:effectLst>
+            <a:scene3d>
+              <a:camera prst="orthographicFront"/>
+              <a:lightRig rig="threePt" dir="t"/>
+            </a:scene3d>
+            <a:sp3d extrusionH="76200" contourW="12700" prstMaterial="matte">
+              <a:bevelT w="152400" h="50800" prst="softRound"/>
+              <a:extrusionClr>
+                <a:schemeClr val="tx2"/>
+              </a:extrusionClr>
+              <a:contourClr>
+                <a:schemeClr val="bg2"/>
+              </a:contourClr>
+            </a:sp3d>
+          </p:spPr>
+          <p:style>
+            <a:lnRef idx="1">
+              <a:schemeClr val="accent1"/>
+            </a:lnRef>
+            <a:fillRef idx="3">
+              <a:schemeClr val="accent1"/>
+            </a:fillRef>
+            <a:effectRef idx="2">
+              <a:schemeClr val="accent1"/>
+            </a:effectRef>
+            <a:fontRef idx="minor">
+              <a:schemeClr val="lt1"/>
+            </a:fontRef>
+          </p:style>
+          <p:txBody>
+            <a:bodyPr rtlCol="0" anchor="ctr"/>
+            <a:lstStyle/>
+            <a:p>
+              <a:pPr algn="ctr"/>
+              <a:endParaRPr lang="en-US"/>
+            </a:p>
+          </p:txBody>
+        </p:sp>
+        <p:sp>
+          <p:nvSpPr>
+            <p:cNvPr id="1033" name="Rectangle 1032">
+              <a:extLst>
+                <a:ext uri="{FF2B5EF4-FFF2-40B4-BE49-F238E27FC236}">
+                  <a16:creationId xmlns:a16="http://schemas.microsoft.com/office/drawing/2014/main" id="{62D4C1CC-A887-4EA5-9B81-A576F5D0FBDF}"/>
+                </a:ext>
+                <a:ext uri="{C183D7F6-B498-43B3-948B-1728B52AA6E4}">
+                  <adec:decorative xmlns:adec="http://schemas.microsoft.com/office/drawing/2017/decorative" val="1"/>
+                </a:ext>
+              </a:extLst>
+            </p:cNvPr>
+            <p:cNvSpPr/>
+            <p:nvPr>
+              <p:extLst>
+                <p:ext uri="{386F3935-93C4-4BCD-93E2-E3B085C9AB24}">
+                  <p16:designElem xmlns:p16="http://schemas.microsoft.com/office/powerpoint/2015/main" val="1"/>
+                </p:ext>
+              </p:extLst>
+            </p:nvPr>
+          </p:nvSpPr>
+          <p:spPr>
+            <a:xfrm>
+              <a:off x="7239487" y="812507"/>
+              <a:ext cx="4001249" cy="4466452"/>
+            </a:xfrm>
+            <a:prstGeom prst="rect">
+              <a:avLst/>
+            </a:prstGeom>
+            <a:gradFill>
+              <a:gsLst>
+                <a:gs pos="0">
+                  <a:srgbClr val="DADADA"/>
+                </a:gs>
+                <a:gs pos="100000">
+                  <a:srgbClr val="FFFFFE"/>
+                </a:gs>
+              </a:gsLst>
+              <a:lin ang="16200000" scaled="0"/>
+            </a:gradFill>
+            <a:ln w="38100" cmpd="sng">
+              <a:solidFill>
+                <a:schemeClr val="tx2">
+                  <a:lumMod val="25000"/>
+                </a:schemeClr>
+              </a:solidFill>
+              <a:miter lim="800000"/>
+            </a:ln>
+            <a:effectLst>
+              <a:innerShdw blurRad="63500" dist="88900" dir="14100000">
+                <a:srgbClr val="000000">
+                  <a:alpha val="30000"/>
+                </a:srgbClr>
+              </a:innerShdw>
+            </a:effectLst>
+            <a:scene3d>
+              <a:camera prst="orthographicFront"/>
+              <a:lightRig rig="threePt" dir="t"/>
+            </a:scene3d>
+            <a:sp3d>
+              <a:bevelT prst="relaxedInset"/>
+            </a:sp3d>
+          </p:spPr>
+          <p:style>
+            <a:lnRef idx="1">
+              <a:schemeClr val="accent1"/>
+            </a:lnRef>
+            <a:fillRef idx="3">
+              <a:schemeClr val="accent1"/>
+            </a:fillRef>
+            <a:effectRef idx="2">
+              <a:schemeClr val="accent1"/>
+            </a:effectRef>
+            <a:fontRef idx="minor">
+              <a:schemeClr val="lt1"/>
+            </a:fontRef>
+          </p:style>
+          <p:txBody>
+            <a:bodyPr rtlCol="0" anchor="ctr"/>
+            <a:lstStyle/>
+            <a:p>
+              <a:pPr algn="ctr"/>
+              <a:endParaRPr lang="en-US"/>
+            </a:p>
+          </p:txBody>
+        </p:sp>
+      </p:grpSp>
+      <p:pic>
+        <p:nvPicPr>
+          <p:cNvPr id="1026" name="Picture 2" descr="A red flower with a yellow center in the middle · Free Stock Photo">
+            <a:extLst>
+              <a:ext uri="{FF2B5EF4-FFF2-40B4-BE49-F238E27FC236}">
+                <a16:creationId xmlns:a16="http://schemas.microsoft.com/office/drawing/2014/main" id="{1A70226F-CFA4-5E76-D04A-592586A8E001}"/>
+              </a:ext>
+            </a:extLst>
+          </p:cNvPr>
+          <p:cNvPicPr>
+            <a:picLocks noChangeAspect="1" noChangeArrowheads="1"/>
+          </p:cNvPicPr>
+          <p:nvPr/>
+        </p:nvPicPr>
+        <p:blipFill>
+          <a:blip r:embed="rId3">
+            <a:extLst>
+              <a:ext uri="{28A0092B-C50C-407E-A947-70E740481C1C}">
+                <a14:useLocalDpi xmlns:a14="http://schemas.microsoft.com/office/drawing/2010/main" val="0"/>
+              </a:ext>
+            </a:extLst>
+          </a:blip>
+          <a:srcRect l="21857" r="16003" b="-1"/>
+          <a:stretch>
+            <a:fillRect/>
+          </a:stretch>
+        </p:blipFill>
+        <p:spPr bwMode="auto">
+          <a:xfrm>
+            <a:off x="7555450" y="1116345"/>
+            <a:ext cx="3360025" cy="3866172"/>
+          </a:xfrm>
+          <a:prstGeom prst="rect">
             <a:avLst/>
           </a:prstGeom>
-          <a:ln w="44450">
-            <a:solidFill>
-              <a:srgbClr val="FFFFFF"/>
-            </a:solidFill>
-          </a:ln>
-          <a:effectLst>
-            <a:outerShdw blurRad="50800" dist="38100" dir="2700000" sx="88000" sy="88000" algn="tl" rotWithShape="0">
-              <a:prstClr val="black">
-                <a:alpha val="26000"/>
-              </a:prstClr>
-            </a:outerShdw>
-          </a:effectLst>
+          <a:noFill/>
+          <a:extLst>
+            <a:ext uri="{909E8E84-426E-40DD-AFC4-6F175D3DCCD1}">
+              <a14:hiddenFill xmlns:a14="http://schemas.microsoft.com/office/drawing/2010/main">
+                <a:solidFill>
+                  <a:srgbClr val="FFFFFF"/>
+                </a:solidFill>
+              </a14:hiddenFill>
+            </a:ext>
+          </a:extLst>
         </p:spPr>
-        <p:style>
-          <a:lnRef idx="1">
-            <a:schemeClr val="accent1"/>
-          </a:lnRef>
-          <a:fillRef idx="0">
-            <a:schemeClr val="accent1"/>
-          </a:fillRef>
-          <a:effectRef idx="0">
-            <a:schemeClr val="accent1"/>
-          </a:effectRef>
-          <a:fontRef idx="minor">
-            <a:schemeClr val="tx1"/>
-          </a:fontRef>
-        </p:style>
-      </p:cxnSp>
+      </p:pic>
     </p:spTree>
     <p:extLst>
       <p:ext uri="{BB962C8B-B14F-4D97-AF65-F5344CB8AC3E}">
@@ -3810,8 +3655,147 @@
     </p:extLst>
   </p:cSld>
   <p:clrMapOvr>
-    <a:overrideClrMapping bg1="dk1" tx1="lt1" bg2="dk2" tx2="lt2" accent1="accent1" accent2="accent2" accent3="accent3" accent4="accent4" accent5="accent5" accent6="accent6" hlink="hlink" folHlink="folHlink"/>
+    <a:masterClrMapping/>
   </p:clrMapOvr>
+  <p:timing>
+    <p:tnLst>
+      <p:par>
+        <p:cTn id="1" dur="indefinite" restart="never" nodeType="tmRoot">
+          <p:childTnLst>
+            <p:seq concurrent="1" nextAc="seek">
+              <p:cTn id="2" dur="indefinite" nodeType="mainSeq">
+                <p:childTnLst>
+                  <p:par>
+                    <p:cTn id="3" fill="hold">
+                      <p:stCondLst>
+                        <p:cond delay="indefinite"/>
+                        <p:cond evt="onBegin" delay="0">
+                          <p:tn val="2"/>
+                        </p:cond>
+                      </p:stCondLst>
+                      <p:childTnLst>
+                        <p:par>
+                          <p:cTn id="4" fill="hold">
+                            <p:stCondLst>
+                              <p:cond delay="0"/>
+                            </p:stCondLst>
+                            <p:childTnLst>
+                              <p:par>
+                                <p:cTn id="5" presetID="10" presetClass="entr" presetSubtype="0" fill="hold" grpId="0" nodeType="withEffect">
+                                  <p:stCondLst>
+                                    <p:cond delay="1000"/>
+                                  </p:stCondLst>
+                                  <p:iterate type="lt">
+                                    <p:tmPct val="10000"/>
+                                  </p:iterate>
+                                  <p:childTnLst>
+                                    <p:set>
+                                      <p:cBhvr>
+                                        <p:cTn id="6" dur="1" fill="hold">
+                                          <p:stCondLst>
+                                            <p:cond delay="0"/>
+                                          </p:stCondLst>
+                                        </p:cTn>
+                                        <p:tgtEl>
+                                          <p:spTgt spid="2"/>
+                                        </p:tgtEl>
+                                        <p:attrNameLst>
+                                          <p:attrName>style.visibility</p:attrName>
+                                        </p:attrNameLst>
+                                      </p:cBhvr>
+                                      <p:to>
+                                        <p:strVal val="visible"/>
+                                      </p:to>
+                                    </p:set>
+                                    <p:animEffect transition="in" filter="fade">
+                                      <p:cBhvr>
+                                        <p:cTn id="7" dur="400"/>
+                                        <p:tgtEl>
+                                          <p:spTgt spid="2"/>
+                                        </p:tgtEl>
+                                      </p:cBhvr>
+                                    </p:animEffect>
+                                  </p:childTnLst>
+                                </p:cTn>
+                              </p:par>
+                              <p:par>
+                                <p:cTn id="8" presetID="10" presetClass="entr" presetSubtype="0" fill="hold" grpId="0" nodeType="withEffect">
+                                  <p:stCondLst>
+                                    <p:cond delay="2000"/>
+                                  </p:stCondLst>
+                                  <p:iterate type="lt">
+                                    <p:tmPct val="10000"/>
+                                  </p:iterate>
+                                  <p:childTnLst>
+                                    <p:set>
+                                      <p:cBhvr>
+                                        <p:cTn id="9" dur="1" fill="hold">
+                                          <p:stCondLst>
+                                            <p:cond delay="0"/>
+                                          </p:stCondLst>
+                                        </p:cTn>
+                                        <p:tgtEl>
+                                          <p:spTgt spid="3">
+                                            <p:txEl>
+                                              <p:pRg st="0" end="0"/>
+                                            </p:txEl>
+                                          </p:spTgt>
+                                        </p:tgtEl>
+                                        <p:attrNameLst>
+                                          <p:attrName>style.visibility</p:attrName>
+                                        </p:attrNameLst>
+                                      </p:cBhvr>
+                                      <p:to>
+                                        <p:strVal val="visible"/>
+                                      </p:to>
+                                    </p:set>
+                                    <p:animEffect transition="in" filter="fade">
+                                      <p:cBhvr>
+                                        <p:cTn id="10" dur="400"/>
+                                        <p:tgtEl>
+                                          <p:spTgt spid="3">
+                                            <p:txEl>
+                                              <p:pRg st="0" end="0"/>
+                                            </p:txEl>
+                                          </p:spTgt>
+                                        </p:tgtEl>
+                                      </p:cBhvr>
+                                    </p:animEffect>
+                                  </p:childTnLst>
+                                </p:cTn>
+                              </p:par>
+                            </p:childTnLst>
+                          </p:cTn>
+                        </p:par>
+                      </p:childTnLst>
+                    </p:cTn>
+                  </p:par>
+                </p:childTnLst>
+              </p:cTn>
+              <p:prevCondLst>
+                <p:cond evt="onPrev" delay="0">
+                  <p:tgtEl>
+                    <p:sldTgt/>
+                  </p:tgtEl>
+                </p:cond>
+              </p:prevCondLst>
+              <p:nextCondLst>
+                <p:cond evt="onNext" delay="0">
+                  <p:tgtEl>
+                    <p:sldTgt/>
+                  </p:tgtEl>
+                </p:cond>
+              </p:nextCondLst>
+            </p:seq>
+          </p:childTnLst>
+        </p:cTn>
+      </p:par>
+    </p:tnLst>
+    <p:bldLst>
+      <p:bldP spid="2" grpId="0"/>
+      <p:bldP spid="3" grpId="0" build="p"/>
+    </p:bldLst>
+  </p:timing>
 </p:sld>
 </file>
 
@@ -3926,8 +3910,8 @@
         </p:nvSpPr>
         <p:spPr>
           <a:xfrm flipH="1">
-            <a:off x="700635" y="5574268"/>
-            <a:ext cx="4492072" cy="369332"/>
+            <a:off x="700634" y="5574268"/>
+            <a:ext cx="5850067" cy="369332"/>
           </a:xfrm>
           <a:prstGeom prst="rect">
             <a:avLst/>
@@ -4142,7 +4126,9 @@
           </a:xfrm>
         </p:spPr>
         <p:txBody>
-          <a:bodyPr/>
+          <a:bodyPr>
+            <a:normAutofit/>
+          </a:bodyPr>
           <a:lstStyle/>
           <a:p>
             <a:r>
@@ -4203,7 +4189,7 @@
         <p:spPr>
           <a:xfrm>
             <a:off x="6400801" y="2221992"/>
-            <a:ext cx="4991099" cy="6963060"/>
+            <a:ext cx="4991099" cy="6961778"/>
           </a:xfrm>
           <a:prstGeom prst="rect">
             <a:avLst/>
@@ -4272,7 +4258,23 @@
             </a:pPr>
             <a:r>
               <a:rPr lang="en-US" sz="2000" dirty="0"/>
-              <a:t>Settings/Popup menu(change background color)</a:t>
+              <a:t>Settings/Popup menu(</a:t>
+            </a:r>
+            <a:r>
+              <a:rPr lang="en-US" sz="2000" dirty="0" err="1"/>
+              <a:t>darkmode</a:t>
+            </a:r>
+            <a:r>
+              <a:rPr lang="en-US" sz="2000" dirty="0"/>
+              <a:t>, volume. </a:t>
+            </a:r>
+            <a:r>
+              <a:rPr lang="en-US" sz="2000" dirty="0" err="1"/>
+              <a:t>etc</a:t>
+            </a:r>
+            <a:r>
+              <a:rPr lang="en-US" sz="2000" dirty="0"/>
+              <a:t>)</a:t>
             </a:r>
           </a:p>
           <a:p>
@@ -4380,6 +4382,76 @@
               <a:buChar char="•"/>
             </a:pPr>
             <a:endParaRPr lang="en-US" sz="2000" dirty="0"/>
+          </a:p>
+        </p:txBody>
+      </p:sp>
+      <p:sp>
+        <p:nvSpPr>
+          <p:cNvPr id="3" name="TextBox 2">
+            <a:extLst>
+              <a:ext uri="{FF2B5EF4-FFF2-40B4-BE49-F238E27FC236}">
+                <a16:creationId xmlns:a16="http://schemas.microsoft.com/office/drawing/2014/main" id="{09695366-E426-30AE-E46B-7F02916936F2}"/>
+              </a:ext>
+            </a:extLst>
+          </p:cNvPr>
+          <p:cNvSpPr txBox="1"/>
+          <p:nvPr/>
+        </p:nvSpPr>
+        <p:spPr>
+          <a:xfrm>
+            <a:off x="700636" y="1727248"/>
+            <a:ext cx="4086693" cy="461665"/>
+          </a:xfrm>
+          <a:prstGeom prst="rect">
+            <a:avLst/>
+          </a:prstGeom>
+          <a:noFill/>
+        </p:spPr>
+        <p:txBody>
+          <a:bodyPr wrap="square" rtlCol="0">
+            <a:spAutoFit/>
+          </a:bodyPr>
+          <a:lstStyle/>
+          <a:p>
+            <a:r>
+              <a:rPr lang="en-US" sz="2400" dirty="0"/>
+              <a:t>Back End:</a:t>
+            </a:r>
+          </a:p>
+        </p:txBody>
+      </p:sp>
+      <p:sp>
+        <p:nvSpPr>
+          <p:cNvPr id="4" name="TextBox 3">
+            <a:extLst>
+              <a:ext uri="{FF2B5EF4-FFF2-40B4-BE49-F238E27FC236}">
+                <a16:creationId xmlns:a16="http://schemas.microsoft.com/office/drawing/2014/main" id="{660E9E7B-7D89-01FC-FA4C-DF6E0451C5B0}"/>
+              </a:ext>
+            </a:extLst>
+          </p:cNvPr>
+          <p:cNvSpPr txBox="1"/>
+          <p:nvPr/>
+        </p:nvSpPr>
+        <p:spPr>
+          <a:xfrm>
+            <a:off x="6400801" y="1727224"/>
+            <a:ext cx="3501510" cy="461665"/>
+          </a:xfrm>
+          <a:prstGeom prst="rect">
+            <a:avLst/>
+          </a:prstGeom>
+          <a:noFill/>
+        </p:spPr>
+        <p:txBody>
+          <a:bodyPr wrap="square" rtlCol="0">
+            <a:spAutoFit/>
+          </a:bodyPr>
+          <a:lstStyle/>
+          <a:p>
+            <a:r>
+              <a:rPr lang="en-US" sz="2400" dirty="0"/>
+              <a:t>Front End &amp; UX</a:t>
+            </a:r>
           </a:p>
         </p:txBody>
       </p:sp>
@@ -4459,24 +4531,38 @@
         </p:nvSpPr>
         <p:spPr/>
         <p:txBody>
-          <a:bodyPr/>
+          <a:bodyPr>
+            <a:normAutofit fontScale="85000" lnSpcReduction="10000"/>
+          </a:bodyPr>
           <a:lstStyle/>
           <a:p>
             <a:r>
               <a:rPr lang="en-US" dirty="0"/>
-              <a:t>The application begins with Log In page</a:t>
+              <a:t>The application begins with a splash screen that displays our logo and names.</a:t>
             </a:r>
           </a:p>
           <a:p>
             <a:r>
               <a:rPr lang="en-US" dirty="0"/>
-              <a:t>The Main Game screen will display after the user logs in.</a:t>
+              <a:t>Then the game will enter the main menu that displays Play, Login and Quit</a:t>
             </a:r>
           </a:p>
           <a:p>
             <a:r>
               <a:rPr lang="en-US" dirty="0"/>
-              <a:t>If the user selects forget password, route to another screen.</a:t>
+              <a:t>If the user clicks login, prompt the user to login.</a:t>
+            </a:r>
+          </a:p>
+          <a:p>
+            <a:r>
+              <a:rPr lang="en-US" dirty="0"/>
+              <a:t>If the user selects register, route to register screen.</a:t>
+            </a:r>
+          </a:p>
+          <a:p>
+            <a:r>
+              <a:rPr lang="en-US" dirty="0"/>
+              <a:t>Once the user clicks play, they will be routed to the main game.</a:t>
             </a:r>
           </a:p>
           <a:p>
@@ -4797,7 +4883,9 @@
         </p:nvSpPr>
         <p:spPr/>
         <p:txBody>
-          <a:bodyPr/>
+          <a:bodyPr>
+            <a:normAutofit fontScale="92500" lnSpcReduction="10000"/>
+          </a:bodyPr>
           <a:lstStyle/>
           <a:p>
             <a:r>
@@ -4850,6 +4938,27 @@
               <a:t>Kiarabartuccio</a:t>
             </a:r>
             <a:endParaRPr lang="en-US" dirty="0"/>
+          </a:p>
+          <a:p>
+            <a:pPr marL="0" indent="0">
+              <a:buNone/>
+            </a:pPr>
+            <a:r>
+              <a:rPr lang="en-US" dirty="0"/>
+              <a:t>Mockup:</a:t>
+            </a:r>
+          </a:p>
+          <a:p>
+            <a:pPr marL="0" indent="0">
+              <a:buNone/>
+            </a:pPr>
+            <a:r>
+              <a:rPr lang="en-CA" dirty="0">
+                <a:hlinkClick r:id="rId3"/>
+              </a:rPr>
+              <a:t>https://www.figma.com/make/AuwvSQ1reE6lIlFVZbPo0m/Mobile-Game-Development?t=SQB13YWjqn0oM0GU-1&amp;preview-route=%2Fgame</a:t>
+            </a:r>
+            <a:endParaRPr lang="en-CA" dirty="0"/>
           </a:p>
         </p:txBody>
       </p:sp>
@@ -4901,16 +5010,18 @@
         </p:nvSpPr>
         <p:spPr>
           <a:xfrm>
-            <a:off x="4622896" y="2775204"/>
-            <a:ext cx="2946208" cy="1307592"/>
+            <a:off x="2935562" y="2121408"/>
+            <a:ext cx="6320875" cy="1307592"/>
           </a:xfrm>
         </p:spPr>
         <p:txBody>
-          <a:bodyPr/>
-          <a:lstStyle/>
-          <a:p>
-            <a:r>
-              <a:rPr lang="en-US" dirty="0"/>
+          <a:bodyPr>
+            <a:noAutofit/>
+          </a:bodyPr>
+          <a:lstStyle/>
+          <a:p>
+            <a:r>
+              <a:rPr lang="en-US" sz="7200" dirty="0"/>
               <a:t>Thank You!</a:t>
             </a:r>
           </a:p>
@@ -4930,59 +5041,119 @@
 </file>
 
 <file path=ppt/theme/theme1.xml><?xml version="1.0" encoding="utf-8"?>
-<a:theme xmlns:a="http://schemas.openxmlformats.org/drawingml/2006/main" name="ChronicleVTI">
+<a:theme xmlns:a="http://schemas.openxmlformats.org/drawingml/2006/main" name="Gallery">
   <a:themeElements>
-    <a:clrScheme name="Chronicle">
+    <a:clrScheme name="Gallery">
       <a:dk1>
-        <a:srgbClr val="000000"/>
+        <a:sysClr val="windowText" lastClr="000000"/>
       </a:dk1>
       <a:lt1>
-        <a:srgbClr val="FFFFFF"/>
+        <a:sysClr val="window" lastClr="FFFFFF"/>
       </a:lt1>
       <a:dk2>
-        <a:srgbClr val="1C1C32"/>
+        <a:srgbClr val="454545"/>
       </a:dk2>
       <a:lt2>
-        <a:srgbClr val="F8F4F1"/>
+        <a:srgbClr val="DFD9D5"/>
       </a:lt2>
       <a:accent1>
-        <a:srgbClr val="734B67"/>
+        <a:srgbClr val="FB8C29"/>
       </a:accent1>
       <a:accent2>
-        <a:srgbClr val="959EBB"/>
+        <a:srgbClr val="F2C351"/>
       </a:accent2>
       <a:accent3>
-        <a:srgbClr val="596781"/>
+        <a:srgbClr val="D0CBA5"/>
       </a:accent3>
       <a:accent4>
-        <a:srgbClr val="7F6E8C"/>
+        <a:srgbClr val="A2C476"/>
       </a:accent4>
       <a:accent5>
-        <a:srgbClr val="DB9A8F"/>
+        <a:srgbClr val="57C293"/>
       </a:accent5>
       <a:accent6>
-        <a:srgbClr val="C29AB1"/>
+        <a:srgbClr val="06BFDE"/>
       </a:accent6>
       <a:hlink>
-        <a:srgbClr val="778BA2"/>
+        <a:srgbClr val="FBAE29"/>
       </a:hlink>
       <a:folHlink>
-        <a:srgbClr val="A27C99"/>
+        <a:srgbClr val="EDC47E"/>
       </a:folHlink>
     </a:clrScheme>
-    <a:fontScheme name="Univers Calisto">
+    <a:fontScheme name="Gallery">
       <a:majorFont>
-        <a:latin typeface="Univers Condensed"/>
+        <a:latin typeface="Rockwell" panose="02060603020205020403"/>
         <a:ea typeface=""/>
         <a:cs typeface=""/>
+        <a:font script="Jpan" typeface="游ゴシック Light"/>
+        <a:font script="Hang" typeface="맑은 고딕"/>
+        <a:font script="Hans" typeface="等线 Light"/>
+        <a:font script="Hant" typeface="新細明體"/>
+        <a:font script="Arab" typeface="Times New Roman"/>
+        <a:font script="Hebr" typeface="Times New Roman"/>
+        <a:font script="Thai" typeface="Angsana New"/>
+        <a:font script="Ethi" typeface="Nyala"/>
+        <a:font script="Beng" typeface="Vrinda"/>
+        <a:font script="Gujr" typeface="Shruti"/>
+        <a:font script="Khmr" typeface="MoolBoran"/>
+        <a:font script="Knda" typeface="Tunga"/>
+        <a:font script="Guru" typeface="Raavi"/>
+        <a:font script="Cans" typeface="Euphemia"/>
+        <a:font script="Cher" typeface="Plantagenet Cherokee"/>
+        <a:font script="Yiii" typeface="Microsoft Yi Baiti"/>
+        <a:font script="Tibt" typeface="Microsoft Himalaya"/>
+        <a:font script="Thaa" typeface="MV Boli"/>
+        <a:font script="Deva" typeface="Mangal"/>
+        <a:font script="Telu" typeface="Gautami"/>
+        <a:font script="Taml" typeface="Latha"/>
+        <a:font script="Syrc" typeface="Estrangelo Edessa"/>
+        <a:font script="Orya" typeface="Kalinga"/>
+        <a:font script="Mlym" typeface="Kartika"/>
+        <a:font script="Laoo" typeface="DokChampa"/>
+        <a:font script="Sinh" typeface="Iskoola Pota"/>
+        <a:font script="Mong" typeface="Mongolian Baiti"/>
+        <a:font script="Viet" typeface="Times New Roman"/>
+        <a:font script="Uigh" typeface="Microsoft Uighur"/>
+        <a:font script="Geor" typeface="Sylfaen"/>
       </a:majorFont>
       <a:minorFont>
-        <a:latin typeface="Calisto MT"/>
+        <a:latin typeface="Rockwell" panose="02060603020205020403"/>
         <a:ea typeface=""/>
         <a:cs typeface=""/>
+        <a:font script="Jpan" typeface="游ゴシック"/>
+        <a:font script="Hang" typeface="맑은 고딕"/>
+        <a:font script="Hans" typeface="等线"/>
+        <a:font script="Hant" typeface="新細明體"/>
+        <a:font script="Arab" typeface="Arial"/>
+        <a:font script="Hebr" typeface="Arial"/>
+        <a:font script="Thai" typeface="Cordia New"/>
+        <a:font script="Ethi" typeface="Nyala"/>
+        <a:font script="Beng" typeface="Vrinda"/>
+        <a:font script="Gujr" typeface="Shruti"/>
+        <a:font script="Khmr" typeface="DaunPenh"/>
+        <a:font script="Knda" typeface="Tunga"/>
+        <a:font script="Guru" typeface="Raavi"/>
+        <a:font script="Cans" typeface="Euphemia"/>
+        <a:font script="Cher" typeface="Plantagenet Cherokee"/>
+        <a:font script="Yiii" typeface="Microsoft Yi Baiti"/>
+        <a:font script="Tibt" typeface="Microsoft Himalaya"/>
+        <a:font script="Thaa" typeface="MV Boli"/>
+        <a:font script="Deva" typeface="Mangal"/>
+        <a:font script="Telu" typeface="Gautami"/>
+        <a:font script="Taml" typeface="Latha"/>
+        <a:font script="Syrc" typeface="Estrangelo Edessa"/>
+        <a:font script="Orya" typeface="Kalinga"/>
+        <a:font script="Mlym" typeface="Kartika"/>
+        <a:font script="Laoo" typeface="DokChampa"/>
+        <a:font script="Sinh" typeface="Iskoola Pota"/>
+        <a:font script="Mong" typeface="Mongolian Baiti"/>
+        <a:font script="Viet" typeface="Arial"/>
+        <a:font script="Uigh" typeface="Microsoft Uighur"/>
+        <a:font script="Geor" typeface="Sylfaen"/>
       </a:minorFont>
     </a:fontScheme>
-    <a:fmtScheme name="Office">
+    <a:fmtScheme name="Gallery">
       <a:fillStyleLst>
         <a:solidFill>
           <a:schemeClr val="phClr"/>
@@ -4991,23 +5162,18 @@
           <a:gsLst>
             <a:gs pos="0">
               <a:schemeClr val="phClr">
+                <a:tint val="54000"/>
+                <a:alpha val="100000"/>
+                <a:satMod val="105000"/>
                 <a:lumMod val="110000"/>
-                <a:satMod val="105000"/>
-                <a:tint val="67000"/>
-              </a:schemeClr>
-            </a:gs>
-            <a:gs pos="50000">
-              <a:schemeClr val="phClr">
-                <a:lumMod val="105000"/>
-                <a:satMod val="103000"/>
-                <a:tint val="73000"/>
               </a:schemeClr>
             </a:gs>
             <a:gs pos="100000">
               <a:schemeClr val="phClr">
-                <a:lumMod val="105000"/>
+                <a:tint val="78000"/>
+                <a:alpha val="92000"/>
                 <a:satMod val="109000"/>
-                <a:tint val="81000"/>
+                <a:lumMod val="100000"/>
               </a:schemeClr>
             </a:gs>
           </a:gsLst>
@@ -5017,23 +5183,23 @@
           <a:gsLst>
             <a:gs pos="0">
               <a:schemeClr val="phClr">
-                <a:satMod val="103000"/>
-                <a:lumMod val="102000"/>
-                <a:tint val="94000"/>
+                <a:tint val="98000"/>
+                <a:satMod val="110000"/>
+                <a:lumMod val="104000"/>
               </a:schemeClr>
             </a:gs>
-            <a:gs pos="50000">
+            <a:gs pos="69000">
               <a:schemeClr val="phClr">
-                <a:satMod val="110000"/>
-                <a:lumMod val="100000"/>
-                <a:shade val="100000"/>
+                <a:shade val="88000"/>
+                <a:satMod val="130000"/>
+                <a:lumMod val="92000"/>
               </a:schemeClr>
             </a:gs>
             <a:gs pos="100000">
               <a:schemeClr val="phClr">
-                <a:lumMod val="99000"/>
-                <a:satMod val="120000"/>
                 <a:shade val="78000"/>
+                <a:satMod val="130000"/>
+                <a:lumMod val="92000"/>
               </a:schemeClr>
             </a:gs>
           </a:gsLst>
@@ -5041,26 +5207,23 @@
         </a:gradFill>
       </a:fillStyleLst>
       <a:lnStyleLst>
-        <a:ln w="6350" cap="flat" cmpd="sng" algn="ctr">
+        <a:ln w="9525" cap="flat" cmpd="sng" algn="ctr">
           <a:solidFill>
             <a:schemeClr val="phClr"/>
           </a:solidFill>
           <a:prstDash val="solid"/>
-          <a:miter lim="800000"/>
         </a:ln>
-        <a:ln w="12700" cap="flat" cmpd="sng" algn="ctr">
+        <a:ln w="15875" cap="flat" cmpd="sng" algn="ctr">
           <a:solidFill>
             <a:schemeClr val="phClr"/>
           </a:solidFill>
           <a:prstDash val="solid"/>
-          <a:miter lim="800000"/>
         </a:ln>
-        <a:ln w="19050" cap="flat" cmpd="sng" algn="ctr">
+        <a:ln w="22225" cap="flat" cmpd="sng" algn="ctr">
           <a:solidFill>
             <a:schemeClr val="phClr"/>
           </a:solidFill>
           <a:prstDash val="solid"/>
-          <a:miter lim="800000"/>
         </a:ln>
       </a:lnStyleLst>
       <a:effectStyleLst>
@@ -5072,12 +5235,23 @@
         </a:effectStyle>
         <a:effectStyle>
           <a:effectLst>
-            <a:outerShdw blurRad="57150" dist="19050" dir="5400000" algn="ctr" rotWithShape="0">
+            <a:outerShdw blurRad="50800" dist="50800" dir="5400000" sx="96000" sy="96000" rotWithShape="0">
               <a:srgbClr val="000000">
-                <a:alpha val="63000"/>
+                <a:alpha val="48000"/>
               </a:srgbClr>
             </a:outerShdw>
           </a:effectLst>
+          <a:scene3d>
+            <a:camera prst="orthographicFront">
+              <a:rot lat="0" lon="0" rev="0"/>
+            </a:camera>
+            <a:lightRig rig="balanced" dir="t">
+              <a:rot lat="0" lon="0" rev="1080000"/>
+            </a:lightRig>
+          </a:scene3d>
+          <a:sp3d>
+            <a:bevelT w="38100" h="12700" prst="softRound"/>
+          </a:sp3d>
         </a:effectStyle>
       </a:effectStyleLst>
       <a:bgFillStyleLst>
@@ -5085,92 +5259,35 @@
           <a:schemeClr val="phClr"/>
         </a:solidFill>
         <a:solidFill>
-          <a:schemeClr val="phClr">
-            <a:tint val="95000"/>
-            <a:satMod val="170000"/>
-          </a:schemeClr>
+          <a:schemeClr val="phClr"/>
         </a:solidFill>
         <a:gradFill rotWithShape="1">
           <a:gsLst>
             <a:gs pos="0">
               <a:schemeClr val="phClr">
-                <a:tint val="93000"/>
-                <a:satMod val="150000"/>
-                <a:shade val="98000"/>
-                <a:lumMod val="102000"/>
-              </a:schemeClr>
-            </a:gs>
-            <a:gs pos="50000">
-              <a:schemeClr val="phClr">
-                <a:tint val="98000"/>
-                <a:satMod val="130000"/>
-                <a:shade val="90000"/>
-                <a:lumMod val="103000"/>
+                <a:tint val="94000"/>
+                <a:satMod val="80000"/>
+                <a:lumMod val="106000"/>
               </a:schemeClr>
             </a:gs>
             <a:gs pos="100000">
               <a:schemeClr val="phClr">
-                <a:shade val="63000"/>
-                <a:satMod val="120000"/>
+                <a:shade val="80000"/>
               </a:schemeClr>
             </a:gs>
           </a:gsLst>
-          <a:lin ang="5400000" scaled="0"/>
+          <a:path path="circle">
+            <a:fillToRect l="50000" t="50000" r="50000" b="50000"/>
+          </a:path>
         </a:gradFill>
       </a:bgFillStyleLst>
     </a:fmtScheme>
   </a:themeElements>
-  <a:objectDefaults>
-    <a:spDef>
-      <a:spPr>
-        <a:ln w="12700" cap="flat" cmpd="sng" algn="ctr">
-          <a:noFill/>
-          <a:prstDash val="solid"/>
-          <a:miter lim="800000"/>
-        </a:ln>
-        <a:effectLst/>
-        <a:extLst>
-          <a:ext uri="{91240B29-F687-4F45-9708-019B960494DF}">
-            <a14:hiddenLine xmlns:a14="http://schemas.microsoft.com/office/drawing/2010/main" w="12700" cap="flat" cmpd="sng" algn="ctr">
-              <a:solidFill>
-                <a:schemeClr val="accent1">
-                  <a:shade val="50000"/>
-                </a:schemeClr>
-              </a:solidFill>
-              <a:prstDash val="solid"/>
-              <a:miter lim="800000"/>
-            </a14:hiddenLine>
-          </a:ext>
-        </a:extLst>
-      </a:spPr>
-      <a:bodyPr rtlCol="0" anchor="ctr"/>
-      <a:lstStyle>
-        <a:defPPr algn="ctr">
-          <a:defRPr/>
-        </a:defPPr>
-      </a:lstStyle>
-      <a:style>
-        <a:lnRef idx="2">
-          <a:schemeClr val="accent1">
-            <a:shade val="50000"/>
-          </a:schemeClr>
-        </a:lnRef>
-        <a:fillRef idx="1">
-          <a:schemeClr val="accent1"/>
-        </a:fillRef>
-        <a:effectRef idx="0">
-          <a:schemeClr val="accent1"/>
-        </a:effectRef>
-        <a:fontRef idx="minor">
-          <a:schemeClr val="lt1"/>
-        </a:fontRef>
-      </a:style>
-    </a:spDef>
-  </a:objectDefaults>
+  <a:objectDefaults/>
   <a:extraClrSchemeLst/>
   <a:extLst>
     <a:ext uri="{05A4C25C-085E-4340-85A3-A5531E510DB2}">
-      <thm15:themeFamily xmlns:thm15="http://schemas.microsoft.com/office/thememl/2012/main" name="ChronicleVTI" id="{508E4D90-5116-4BF0-876B-3F422DD1F65F}" vid="{AA21DC3D-92A8-43A4-8358-ED428371CD55}"/>
+      <thm15:themeFamily xmlns:thm15="http://schemas.microsoft.com/office/thememl/2012/main" name="Gallery" id="{BBFCD31E-59A1-489D-B089-A3EAD7CAE12E}" vid="{BB5F5D82-B5E9-469E-A815-C655ED4AF243}"/>
     </a:ext>
   </a:extLst>
 </a:theme>

</xml_diff>